<commit_message>
Improve GUI layout, preview behavior, and Verilog PSEQCELL output.
Add CYCLE_FORCE/FORCE controls, fix Inv group header clipping and paned column defaults, and stop emitting RECOVER/CYCLE_SYNC/OD on PSEQCELL instances.

Co-authored-by: Cursor <cursoragent@cursor.com>
</commit_message>
<xml_diff>
--- a/doc/PowerSequenceGenerator_v1.3.pptx
+++ b/doc/PowerSequenceGenerator_v1.3.pptx
@@ -5,21 +5,25 @@
     <p:sldMasterId id="2147483663" r:id="rId1"/>
   </p:sldMasterIdLst>
   <p:notesMasterIdLst>
-    <p:notesMasterId r:id="rId6"/>
+    <p:notesMasterId r:id="rId10"/>
   </p:notesMasterIdLst>
   <p:handoutMasterIdLst>
-    <p:handoutMasterId r:id="rId7"/>
+    <p:handoutMasterId r:id="rId11"/>
   </p:handoutMasterIdLst>
   <p:sldIdLst>
     <p:sldId id="256" r:id="rId2"/>
     <p:sldId id="258" r:id="rId3"/>
     <p:sldId id="259" r:id="rId4"/>
     <p:sldId id="260" r:id="rId5"/>
+    <p:sldId id="261" r:id="rId6"/>
+    <p:sldId id="262" r:id="rId7"/>
+    <p:sldId id="263" r:id="rId8"/>
+    <p:sldId id="264" r:id="rId9"/>
   </p:sldIdLst>
   <p:sldSz cx="9144000" cy="5143500" type="screen16x9"/>
   <p:notesSz cx="6662738" cy="9926638"/>
   <p:custDataLst>
-    <p:tags r:id="rId8"/>
+    <p:tags r:id="rId12"/>
   </p:custDataLst>
   <p:defaultTextStyle>
     <a:defPPr>
@@ -248,7 +252,7 @@
             <a:fld id="{AD20BEF9-AA05-4FF8-873E-9941013038D7}" type="datetimeFigureOut">
               <a:rPr lang="zh-TW" altLang="en-US" smtClean="0"/>
               <a:pPr/>
-              <a:t>2026/1/30</a:t>
+              <a:t>2026/6/8</a:t>
             </a:fld>
             <a:endParaRPr lang="zh-TW" altLang="en-US"/>
           </a:p>
@@ -414,7 +418,7 @@
           <a:p>
             <a:fld id="{B5828AD7-229D-4E70-BA7E-76E0859339A6}" type="datetimeFigureOut">
               <a:rPr lang="en-US" smtClean="0"/>
-              <a:t>1/30/2026</a:t>
+              <a:t>6/8/2026</a:t>
             </a:fld>
             <a:endParaRPr lang="en-US"/>
           </a:p>
@@ -4125,19 +4129,8 @@
                 <a:latin typeface="Calibri" panose="020F0502020204030204" pitchFamily="34" charset="0"/>
                 <a:cs typeface="Calibri" panose="020F0502020204030204" pitchFamily="34" charset="0"/>
               </a:rPr>
-              <a:t>CPLD </a:t>
-            </a:r>
-            <a:r>
-              <a:rPr lang="en-US" altLang="zh-TW" sz="2400" dirty="0">
-                <a:latin typeface="Calibri" panose="020F0502020204030204" pitchFamily="34" charset="0"/>
-                <a:cs typeface="Calibri" panose="020F0502020204030204" pitchFamily="34" charset="0"/>
-              </a:rPr>
-              <a:t>ADC Question</a:t>
-            </a:r>
-            <a:endParaRPr lang="en-US" sz="2400" dirty="0">
-              <a:latin typeface="Calibri" panose="020F0502020204030204" pitchFamily="34" charset="0"/>
-              <a:cs typeface="Calibri" panose="020F0502020204030204" pitchFamily="34" charset="0"/>
-            </a:endParaRPr>
+              <a:t>Power Sequence Generator</a:t>
+            </a:r>
           </a:p>
         </p:txBody>
       </p:sp>
@@ -4177,7 +4170,7 @@
           <a:p>
             <a:r>
               <a:rPr lang="en-US" dirty="0"/>
-              <a:t>1/30/2026</a:t>
+              <a:t>6/08/2026</a:t>
             </a:r>
           </a:p>
         </p:txBody>
@@ -4235,7 +4228,7 @@
           <a:p>
             <a:r>
               <a:rPr lang="en-US" altLang="zh-TW" dirty="0"/>
-              <a:t>ADC Structure</a:t>
+              <a:t>Why this tool?</a:t>
             </a:r>
             <a:endParaRPr lang="zh-TW" altLang="en-US" dirty="0"/>
           </a:p>
@@ -4290,7 +4283,7 @@
         <p:spPr>
           <a:xfrm>
             <a:off x="228600" y="671891"/>
-            <a:ext cx="8610600" cy="3042859"/>
+            <a:ext cx="8610600" cy="1442659"/>
           </a:xfrm>
         </p:spPr>
         <p:txBody>
@@ -4306,17 +4299,81 @@
             </a:pPr>
             <a:r>
               <a:rPr lang="en-US" dirty="0"/>
-              <a:t>In the document “Simple Sigma-delta ADC Reference Design”, the LVDS input is used as a comparator.</a:t>
-            </a:r>
+              <a:t>One model – many deliverables</a:t>
+            </a:r>
+          </a:p>
+          <a:p>
+            <a:pPr lvl="1">
+              <a:buSzPct val="100000"/>
+              <a:buFont typeface="Arial" panose="020B0604020202020204" pitchFamily="34" charset="0"/>
+              <a:buChar char="•"/>
+            </a:pPr>
+            <a:r>
+              <a:rPr lang="en-US" dirty="0"/>
+              <a:t>Power-up/down has many rails, PG signals, and timing constraints.</a:t>
+            </a:r>
+          </a:p>
+          <a:p>
+            <a:pPr lvl="1">
+              <a:buSzPct val="100000"/>
+              <a:buFont typeface="Arial" panose="020B0604020202020204" pitchFamily="34" charset="0"/>
+              <a:buChar char="•"/>
+            </a:pPr>
+            <a:r>
+              <a:rPr lang="en-US" dirty="0"/>
+              <a:t>Specs drift when JSON, RTL, firmware, and diagrams are edited by hand.</a:t>
+            </a:r>
+          </a:p>
+          <a:p>
+            <a:pPr lvl="1">
+              <a:buSzPct val="100000"/>
+              <a:buFont typeface="Arial" panose="020B0604020202020204" pitchFamily="34" charset="0"/>
+              <a:buChar char="•"/>
+            </a:pPr>
+            <a:r>
+              <a:rPr lang="en-US" dirty="0" err="1"/>
+              <a:t>PowerSequenceGenerator</a:t>
+            </a:r>
+            <a:r>
+              <a:rPr lang="en-US" dirty="0"/>
+              <a:t> keeps one JSON source of truth.</a:t>
+            </a:r>
+          </a:p>
+          <a:p>
+            <a:pPr lvl="2">
+              <a:buSzPct val="100000"/>
+              <a:buFont typeface="Arial" panose="020B0604020202020204" pitchFamily="34" charset="0"/>
+              <a:buChar char="•"/>
+            </a:pPr>
+            <a:r>
+              <a:rPr lang="en-US" dirty="0"/>
+              <a:t>It generates Verilog, C Code, Draw.io, and </a:t>
+            </a:r>
+            <a:r>
+              <a:rPr lang="en-US" dirty="0" err="1"/>
+              <a:t>WaveDrom</a:t>
+            </a:r>
+            <a:r>
+              <a:rPr lang="en-US" dirty="0"/>
+              <a:t> from the same graph.</a:t>
+            </a:r>
+          </a:p>
+          <a:p>
+            <a:pPr>
+              <a:buSzPct val="100000"/>
+              <a:buFont typeface="Arial" panose="020B0604020202020204" pitchFamily="34" charset="0"/>
+              <a:buChar char="•"/>
+            </a:pPr>
+            <a:endParaRPr lang="en-US" dirty="0"/>
           </a:p>
         </p:txBody>
       </p:sp>
       <p:pic>
         <p:nvPicPr>
-          <p:cNvPr id="6" name="Picture 5">
+          <p:cNvPr id="10" name="Picture 9">
             <a:extLst>
               <a:ext uri="{FF2B5EF4-FFF2-40B4-BE49-F238E27FC236}">
-                <a16:creationId xmlns:a16="http://schemas.microsoft.com/office/drawing/2014/main" id="{C25CE55E-771D-DDCE-E271-4DBCD02059C3}"/>
+                <a16:creationId xmlns:a16="http://schemas.microsoft.com/office/drawing/2014/main" id="{BCD84B79-6DD0-C0D2-DBE5-B77095EBED78}"/>
               </a:ext>
             </a:extLst>
           </p:cNvPr>
@@ -4326,45 +4383,21 @@
           <p:nvPr/>
         </p:nvPicPr>
         <p:blipFill>
-          <a:blip r:embed="rId2"/>
+          <a:blip r:embed="rId2">
+            <a:extLst>
+              <a:ext uri="{28A0092B-C50C-407E-A947-70E740481C1C}">
+                <a14:useLocalDpi xmlns:a14="http://schemas.microsoft.com/office/drawing/2010/main" val="0"/>
+              </a:ext>
+            </a:extLst>
+          </a:blip>
           <a:stretch>
             <a:fillRect/>
           </a:stretch>
         </p:blipFill>
         <p:spPr>
           <a:xfrm>
-            <a:off x="3657600" y="2848694"/>
-            <a:ext cx="3352802" cy="1732112"/>
-          </a:xfrm>
-          <a:prstGeom prst="rect">
-            <a:avLst/>
-          </a:prstGeom>
-        </p:spPr>
-      </p:pic>
-      <p:pic>
-        <p:nvPicPr>
-          <p:cNvPr id="8" name="Picture 7">
-            <a:extLst>
-              <a:ext uri="{FF2B5EF4-FFF2-40B4-BE49-F238E27FC236}">
-                <a16:creationId xmlns:a16="http://schemas.microsoft.com/office/drawing/2014/main" id="{CB7B4C3D-A9AA-D700-2253-1C0724289CD4}"/>
-              </a:ext>
-            </a:extLst>
-          </p:cNvPr>
-          <p:cNvPicPr>
-            <a:picLocks noChangeAspect="1"/>
-          </p:cNvPicPr>
-          <p:nvPr/>
-        </p:nvPicPr>
-        <p:blipFill>
-          <a:blip r:embed="rId3"/>
-          <a:stretch>
-            <a:fillRect/>
-          </a:stretch>
-        </p:blipFill>
-        <p:spPr>
-          <a:xfrm>
-            <a:off x="500672" y="1291468"/>
-            <a:ext cx="5410200" cy="1308138"/>
+            <a:off x="6553199" y="785880"/>
+            <a:ext cx="1905001" cy="3784374"/>
           </a:xfrm>
           <a:prstGeom prst="rect">
             <a:avLst/>
@@ -4406,7 +4439,7 @@
           <p:cNvPr id="2" name="Title 1">
             <a:extLst>
               <a:ext uri="{FF2B5EF4-FFF2-40B4-BE49-F238E27FC236}">
-                <a16:creationId xmlns:a16="http://schemas.microsoft.com/office/drawing/2014/main" id="{D780B1F1-FBC4-F3C1-7096-8394BD1FD8E5}"/>
+                <a16:creationId xmlns:a16="http://schemas.microsoft.com/office/drawing/2014/main" id="{09A0E406-6580-0134-DDC2-F8FC53A28051}"/>
               </a:ext>
             </a:extLst>
           </p:cNvPr>
@@ -4424,7 +4457,7 @@
           <a:p>
             <a:r>
               <a:rPr lang="en-US" dirty="0"/>
-              <a:t>LVDS Pin</a:t>
+              <a:t>Configuration model</a:t>
             </a:r>
           </a:p>
         </p:txBody>
@@ -4434,7 +4467,7 @@
           <p:cNvPr id="3" name="Slide Number Placeholder 2">
             <a:extLst>
               <a:ext uri="{FF2B5EF4-FFF2-40B4-BE49-F238E27FC236}">
-                <a16:creationId xmlns:a16="http://schemas.microsoft.com/office/drawing/2014/main" id="{62C6C4AE-6B18-3E0D-E9C8-4EF789372D93}"/>
+                <a16:creationId xmlns:a16="http://schemas.microsoft.com/office/drawing/2014/main" id="{32013706-4836-B787-0F19-BAFDAD1DD48A}"/>
               </a:ext>
             </a:extLst>
           </p:cNvPr>
@@ -4464,7 +4497,7 @@
           <p:cNvPr id="4" name="Content Placeholder 3">
             <a:extLst>
               <a:ext uri="{FF2B5EF4-FFF2-40B4-BE49-F238E27FC236}">
-                <a16:creationId xmlns:a16="http://schemas.microsoft.com/office/drawing/2014/main" id="{E4B25B60-FE63-89F2-C072-5EF6856FE3B1}"/>
+                <a16:creationId xmlns:a16="http://schemas.microsoft.com/office/drawing/2014/main" id="{6B709AC2-0379-0C20-808D-9C96603CECD9}"/>
               </a:ext>
             </a:extLst>
           </p:cNvPr>
@@ -4482,63 +4515,45 @@
           <a:p>
             <a:r>
               <a:rPr lang="en-US" dirty="0"/>
-              <a:t>According to the document “LVDS Tunneling Protocol and Interface (LTPI) User Guide,” the LVDS pin assignments are as follows:</a:t>
+              <a:t>Rails, conditions, validation</a:t>
             </a:r>
           </a:p>
           <a:p>
             <a:pPr lvl="1"/>
             <a:r>
               <a:rPr lang="en-US" dirty="0"/>
-              <a:t>The input LVDS uses </a:t>
-            </a:r>
-            <a:r>
-              <a:rPr lang="en-US" b="1" dirty="0" err="1"/>
-              <a:t>PBxxA</a:t>
-            </a:r>
-            <a:r>
-              <a:rPr lang="en-US" b="1" dirty="0"/>
-              <a:t> / </a:t>
-            </a:r>
-            <a:r>
-              <a:rPr lang="en-US" b="1" dirty="0" err="1"/>
-              <a:t>PBxxB</a:t>
-            </a:r>
+              <a:t>Node = Input (debounce) or Output (PSEQCELL).</a:t>
+            </a:r>
+          </a:p>
+          <a:p>
+            <a:pPr lvl="1"/>
             <a:r>
               <a:rPr lang="en-US" dirty="0"/>
-              <a:t>.</a:t>
+              <a:t>Hi / Lo Force: AND inside group, OR across groups.</a:t>
             </a:r>
           </a:p>
           <a:p>
             <a:pPr lvl="1"/>
             <a:r>
               <a:rPr lang="en-US" dirty="0"/>
-              <a:t>The output LVDS uses </a:t>
-            </a:r>
-            <a:r>
-              <a:rPr lang="en-US" b="1" dirty="0" err="1"/>
-              <a:t>PTxxA</a:t>
-            </a:r>
-            <a:r>
-              <a:rPr lang="en-US" b="1" dirty="0"/>
-              <a:t> / </a:t>
-            </a:r>
-            <a:r>
-              <a:rPr lang="en-US" b="1" dirty="0" err="1"/>
-              <a:t>PTxxB</a:t>
-            </a:r>
+              <a:t>Invert &amp; use-mode (node / Hi / Lo / self feedback).</a:t>
+            </a:r>
+          </a:p>
+          <a:p>
+            <a:pPr lvl="1"/>
             <a:r>
               <a:rPr lang="en-US" dirty="0"/>
-              <a:t>.</a:t>
+              <a:t>Timing: CYCLE_*, RECOVER, INIT, FORCE, OD.</a:t>
             </a:r>
           </a:p>
         </p:txBody>
       </p:sp>
       <p:pic>
         <p:nvPicPr>
-          <p:cNvPr id="8" name="Picture 7">
+          <p:cNvPr id="6" name="Picture 5">
             <a:extLst>
               <a:ext uri="{FF2B5EF4-FFF2-40B4-BE49-F238E27FC236}">
-                <a16:creationId xmlns:a16="http://schemas.microsoft.com/office/drawing/2014/main" id="{E4DFB0D2-ED77-E82F-8C8D-9B10E40DF36B}"/>
+                <a16:creationId xmlns:a16="http://schemas.microsoft.com/office/drawing/2014/main" id="{ABC0D690-F9A7-37B7-52A2-0FD481ABF5BA}"/>
               </a:ext>
             </a:extLst>
           </p:cNvPr>
@@ -4555,8 +4570,38 @@
         </p:blipFill>
         <p:spPr>
           <a:xfrm>
-            <a:off x="457200" y="2343150"/>
-            <a:ext cx="7948722" cy="1991574"/>
+            <a:off x="609600" y="2038350"/>
+            <a:ext cx="3268531" cy="1520371"/>
+          </a:xfrm>
+          <a:prstGeom prst="rect">
+            <a:avLst/>
+          </a:prstGeom>
+        </p:spPr>
+      </p:pic>
+      <p:pic>
+        <p:nvPicPr>
+          <p:cNvPr id="8" name="Picture 7">
+            <a:extLst>
+              <a:ext uri="{FF2B5EF4-FFF2-40B4-BE49-F238E27FC236}">
+                <a16:creationId xmlns:a16="http://schemas.microsoft.com/office/drawing/2014/main" id="{4CF388F3-A6D9-46AA-F376-3B58C34FACF6}"/>
+              </a:ext>
+            </a:extLst>
+          </p:cNvPr>
+          <p:cNvPicPr>
+            <a:picLocks noChangeAspect="1"/>
+          </p:cNvPicPr>
+          <p:nvPr/>
+        </p:nvPicPr>
+        <p:blipFill>
+          <a:blip r:embed="rId3"/>
+          <a:stretch>
+            <a:fillRect/>
+          </a:stretch>
+        </p:blipFill>
+        <p:spPr>
+          <a:xfrm>
+            <a:off x="4704529" y="2038350"/>
+            <a:ext cx="3007059" cy="2488099"/>
           </a:xfrm>
           <a:prstGeom prst="rect">
             <a:avLst/>
@@ -4566,7 +4611,7 @@
     </p:spTree>
     <p:extLst>
       <p:ext uri="{BB962C8B-B14F-4D97-AF65-F5344CB8AC3E}">
-        <p14:creationId xmlns:p14="http://schemas.microsoft.com/office/powerpoint/2010/main" val="604065790"/>
+        <p14:creationId xmlns:p14="http://schemas.microsoft.com/office/powerpoint/2010/main" val="2434528151"/>
       </p:ext>
     </p:extLst>
   </p:cSld>
@@ -4598,7 +4643,7 @@
           <p:cNvPr id="2" name="Title 1">
             <a:extLst>
               <a:ext uri="{FF2B5EF4-FFF2-40B4-BE49-F238E27FC236}">
-                <a16:creationId xmlns:a16="http://schemas.microsoft.com/office/drawing/2014/main" id="{E7AB8A53-32C6-55B2-23A8-2D4EE1FCE207}"/>
+                <a16:creationId xmlns:a16="http://schemas.microsoft.com/office/drawing/2014/main" id="{13C5DC66-08A3-3DF9-1CE9-2DBD5547BA92}"/>
               </a:ext>
             </a:extLst>
           </p:cNvPr>
@@ -4616,7 +4661,7 @@
           <a:p>
             <a:r>
               <a:rPr lang="en-US" dirty="0"/>
-              <a:t>BPN Design</a:t>
+              <a:t>PSEQCELL in RTL</a:t>
             </a:r>
           </a:p>
         </p:txBody>
@@ -4626,7 +4671,7 @@
           <p:cNvPr id="3" name="Slide Number Placeholder 2">
             <a:extLst>
               <a:ext uri="{FF2B5EF4-FFF2-40B4-BE49-F238E27FC236}">
-                <a16:creationId xmlns:a16="http://schemas.microsoft.com/office/drawing/2014/main" id="{40FCC637-BF66-6D9A-E4B5-A6B61E8244E2}"/>
+                <a16:creationId xmlns:a16="http://schemas.microsoft.com/office/drawing/2014/main" id="{7D23FE28-4111-7205-DE67-21919D1C36FE}"/>
               </a:ext>
             </a:extLst>
           </p:cNvPr>
@@ -4656,7 +4701,7 @@
           <p:cNvPr id="4" name="Content Placeholder 3">
             <a:extLst>
               <a:ext uri="{FF2B5EF4-FFF2-40B4-BE49-F238E27FC236}">
-                <a16:creationId xmlns:a16="http://schemas.microsoft.com/office/drawing/2014/main" id="{D1114BC2-4DF8-6EEA-3728-A8DE00EFCCE1}"/>
+                <a16:creationId xmlns:a16="http://schemas.microsoft.com/office/drawing/2014/main" id="{71DF8BFD-7E94-3956-4537-C8149D5E7635}"/>
               </a:ext>
             </a:extLst>
           </p:cNvPr>
@@ -4674,33 +4719,223 @@
           <a:p>
             <a:r>
               <a:rPr lang="en-US" dirty="0"/>
-              <a:t>In our BPN design, why are </a:t>
+              <a:t>Aligned with </a:t>
             </a:r>
             <a:r>
               <a:rPr lang="en-US" dirty="0" err="1"/>
-              <a:t>PTxxA</a:t>
-            </a:r>
+              <a:t>PSEQCELL.v</a:t>
+            </a:r>
+            <a:endParaRPr lang="en-US" dirty="0"/>
+          </a:p>
+          <a:p>
             <a:r>
               <a:rPr lang="en-US" dirty="0"/>
-              <a:t>/</a:t>
+              <a:t>Ports: </a:t>
             </a:r>
             <a:r>
               <a:rPr lang="en-US" dirty="0" err="1"/>
-              <a:t>PTxxB</a:t>
+              <a:t>iHi</a:t>
             </a:r>
             <a:r>
               <a:rPr lang="en-US" dirty="0"/>
-              <a:t> used for the ADC function?</a:t>
-            </a:r>
+              <a:t>, </a:t>
+            </a:r>
+            <a:r>
+              <a:rPr lang="en-US" dirty="0" err="1"/>
+              <a:t>iLo</a:t>
+            </a:r>
+            <a:r>
+              <a:rPr lang="en-US" dirty="0"/>
+              <a:t>, iForce </a:t>
+            </a:r>
+            <a:r>
+              <a:rPr lang="en-US" dirty="0">
+                <a:sym typeface="Wingdings" panose="05000000000000000000" pitchFamily="2" charset="2"/>
+              </a:rPr>
+              <a:t> internal sequence FSM.</a:t>
+            </a:r>
+          </a:p>
+          <a:p>
+            <a:r>
+              <a:rPr lang="en-US" dirty="0">
+                <a:sym typeface="Wingdings" panose="05000000000000000000" pitchFamily="2" charset="2"/>
+              </a:rPr>
+              <a:t>Q maps to </a:t>
+            </a:r>
+            <a:r>
+              <a:rPr lang="en-US" dirty="0" err="1">
+                <a:sym typeface="Wingdings" panose="05000000000000000000" pitchFamily="2" charset="2"/>
+              </a:rPr>
+              <a:t>oRAIL</a:t>
+            </a:r>
+            <a:r>
+              <a:rPr lang="en-US" dirty="0">
+                <a:sym typeface="Wingdings" panose="05000000000000000000" pitchFamily="2" charset="2"/>
+              </a:rPr>
+              <a:t>; ~Q used for feedback paths.</a:t>
+            </a:r>
+          </a:p>
+          <a:p>
+            <a:r>
+              <a:rPr lang="en-US" dirty="0">
+                <a:sym typeface="Wingdings" panose="05000000000000000000" pitchFamily="2" charset="2"/>
+              </a:rPr>
+              <a:t>Parameters from JSON: CYCLE_HI/LO, RECOVER, etc.</a:t>
+            </a:r>
+          </a:p>
+          <a:p>
+            <a:r>
+              <a:rPr lang="en-US" dirty="0">
+                <a:sym typeface="Wingdings" panose="05000000000000000000" pitchFamily="2" charset="2"/>
+              </a:rPr>
+              <a:t>DEB instances for debounced inputs.</a:t>
+            </a:r>
+            <a:endParaRPr lang="en-US" dirty="0"/>
           </a:p>
         </p:txBody>
       </p:sp>
       <p:pic>
         <p:nvPicPr>
-          <p:cNvPr id="6" name="Picture 5">
+          <p:cNvPr id="7" name="Picture 6">
             <a:extLst>
               <a:ext uri="{FF2B5EF4-FFF2-40B4-BE49-F238E27FC236}">
-                <a16:creationId xmlns:a16="http://schemas.microsoft.com/office/drawing/2014/main" id="{CADC25B0-6ABC-D22E-82A4-B1DCEAE90B7D}"/>
+                <a16:creationId xmlns:a16="http://schemas.microsoft.com/office/drawing/2014/main" id="{AD2FA241-C3D2-B169-9688-BE79D6DB2CBA}"/>
+              </a:ext>
+            </a:extLst>
+          </p:cNvPr>
+          <p:cNvPicPr>
+            <a:picLocks noChangeAspect="1"/>
+          </p:cNvPicPr>
+          <p:nvPr/>
+        </p:nvPicPr>
+        <p:blipFill>
+          <a:blip r:embed="rId2">
+            <a:extLst>
+              <a:ext uri="{28A0092B-C50C-407E-A947-70E740481C1C}">
+                <a14:useLocalDpi xmlns:a14="http://schemas.microsoft.com/office/drawing/2010/main" val="0"/>
+              </a:ext>
+            </a:extLst>
+          </a:blip>
+          <a:stretch>
+            <a:fillRect/>
+          </a:stretch>
+        </p:blipFill>
+        <p:spPr>
+          <a:xfrm>
+            <a:off x="5486400" y="2800350"/>
+            <a:ext cx="3048000" cy="1552575"/>
+          </a:xfrm>
+          <a:prstGeom prst="rect">
+            <a:avLst/>
+          </a:prstGeom>
+        </p:spPr>
+      </p:pic>
+    </p:spTree>
+    <p:extLst>
+      <p:ext uri="{BB962C8B-B14F-4D97-AF65-F5344CB8AC3E}">
+        <p14:creationId xmlns:p14="http://schemas.microsoft.com/office/powerpoint/2010/main" val="3637689357"/>
+      </p:ext>
+    </p:extLst>
+  </p:cSld>
+  <p:clrMapOvr>
+    <a:masterClrMapping/>
+  </p:clrMapOvr>
+</p:sld>
+</file>
+
+<file path=ppt/slides/slide5.xml><?xml version="1.0" encoding="utf-8"?>
+<p:sld xmlns:a="http://schemas.openxmlformats.org/drawingml/2006/main" xmlns:r="http://schemas.openxmlformats.org/officeDocument/2006/relationships" xmlns:p="http://schemas.openxmlformats.org/presentationml/2006/main">
+  <p:cSld>
+    <p:spTree>
+      <p:nvGrpSpPr>
+        <p:cNvPr id="1" name=""/>
+        <p:cNvGrpSpPr/>
+        <p:nvPr/>
+      </p:nvGrpSpPr>
+      <p:grpSpPr>
+        <a:xfrm>
+          <a:off x="0" y="0"/>
+          <a:ext cx="0" cy="0"/>
+          <a:chOff x="0" y="0"/>
+          <a:chExt cx="0" cy="0"/>
+        </a:xfrm>
+      </p:grpSpPr>
+      <p:sp>
+        <p:nvSpPr>
+          <p:cNvPr id="2" name="Title 1">
+            <a:extLst>
+              <a:ext uri="{FF2B5EF4-FFF2-40B4-BE49-F238E27FC236}">
+                <a16:creationId xmlns:a16="http://schemas.microsoft.com/office/drawing/2014/main" id="{C3648DAC-BE93-31A0-D0B9-F20BB1606568}"/>
+              </a:ext>
+            </a:extLst>
+          </p:cNvPr>
+          <p:cNvSpPr>
+            <a:spLocks noGrp="1"/>
+          </p:cNvSpPr>
+          <p:nvPr>
+            <p:ph type="title"/>
+          </p:nvPr>
+        </p:nvSpPr>
+        <p:spPr>
+          <a:xfrm>
+            <a:off x="236669" y="89257"/>
+            <a:ext cx="8686799" cy="402335"/>
+          </a:xfrm>
+        </p:spPr>
+        <p:txBody>
+          <a:bodyPr anchor="ctr">
+            <a:normAutofit/>
+          </a:bodyPr>
+          <a:lstStyle/>
+          <a:p>
+            <a:r>
+              <a:rPr lang="en-US" sz="2100"/>
+              <a:t>Verilog Generation</a:t>
+            </a:r>
+          </a:p>
+        </p:txBody>
+      </p:sp>
+      <p:sp>
+        <p:nvSpPr>
+          <p:cNvPr id="4" name="Content Placeholder 3">
+            <a:extLst>
+              <a:ext uri="{FF2B5EF4-FFF2-40B4-BE49-F238E27FC236}">
+                <a16:creationId xmlns:a16="http://schemas.microsoft.com/office/drawing/2014/main" id="{CFBE5B1C-0CCE-274E-A635-DE186842EDA0}"/>
+              </a:ext>
+            </a:extLst>
+          </p:cNvPr>
+          <p:cNvSpPr>
+            <a:spLocks noGrp="1"/>
+          </p:cNvSpPr>
+          <p:nvPr>
+            <p:ph idx="1"/>
+          </p:nvPr>
+        </p:nvSpPr>
+        <p:spPr>
+          <a:xfrm>
+            <a:off x="228600" y="595691"/>
+            <a:ext cx="4245909" cy="4185860"/>
+          </a:xfrm>
+        </p:spPr>
+        <p:txBody>
+          <a:bodyPr>
+            <a:normAutofit/>
+          </a:bodyPr>
+          <a:lstStyle/>
+          <a:p>
+            <a:r>
+              <a:rPr lang="en-US" dirty="0"/>
+              <a:t>Auto-generated module + PSEQCELL instances</a:t>
+            </a:r>
+          </a:p>
+        </p:txBody>
+      </p:sp>
+      <p:pic>
+        <p:nvPicPr>
+          <p:cNvPr id="5" name="Picture 4" descr="demo_verilog_excerpt.png">
+            <a:extLst>
+              <a:ext uri="{FF2B5EF4-FFF2-40B4-BE49-F238E27FC236}">
+                <a16:creationId xmlns:a16="http://schemas.microsoft.com/office/drawing/2014/main" id="{DA02F18A-319E-5CED-0577-CC4065611991}"/>
               </a:ext>
             </a:extLst>
           </p:cNvPr>
@@ -4717,8 +4952,207 @@
         </p:blipFill>
         <p:spPr>
           <a:xfrm>
-            <a:off x="474220" y="1466696"/>
-            <a:ext cx="8211696" cy="2210108"/>
+            <a:off x="4665009" y="1473229"/>
+            <a:ext cx="4245909" cy="2430783"/>
+          </a:xfrm>
+          <a:prstGeom prst="rect">
+            <a:avLst/>
+          </a:prstGeom>
+          <a:noFill/>
+        </p:spPr>
+      </p:pic>
+      <p:sp>
+        <p:nvSpPr>
+          <p:cNvPr id="3" name="Slide Number Placeholder 2">
+            <a:extLst>
+              <a:ext uri="{FF2B5EF4-FFF2-40B4-BE49-F238E27FC236}">
+                <a16:creationId xmlns:a16="http://schemas.microsoft.com/office/drawing/2014/main" id="{F7C76006-54E2-B092-FAA0-91B5E38E2CC0}"/>
+              </a:ext>
+            </a:extLst>
+          </p:cNvPr>
+          <p:cNvSpPr>
+            <a:spLocks noGrp="1"/>
+          </p:cNvSpPr>
+          <p:nvPr>
+            <p:ph type="sldNum" sz="quarter" idx="10"/>
+          </p:nvPr>
+        </p:nvSpPr>
+        <p:spPr/>
+        <p:txBody>
+          <a:bodyPr/>
+          <a:lstStyle/>
+          <a:p>
+            <a:pPr>
+              <a:spcAft>
+                <a:spcPts val="600"/>
+              </a:spcAft>
+            </a:pPr>
+            <a:fld id="{A241CA56-04D4-487E-9E31-9A10C01A108A}" type="slidenum">
+              <a:rPr lang="en-US" smtClean="0"/>
+              <a:pPr>
+                <a:spcAft>
+                  <a:spcPts val="600"/>
+                </a:spcAft>
+              </a:pPr>
+              <a:t>5</a:t>
+            </a:fld>
+            <a:endParaRPr lang="en-US"/>
+          </a:p>
+        </p:txBody>
+      </p:sp>
+    </p:spTree>
+    <p:extLst>
+      <p:ext uri="{BB962C8B-B14F-4D97-AF65-F5344CB8AC3E}">
+        <p14:creationId xmlns:p14="http://schemas.microsoft.com/office/powerpoint/2010/main" val="1665871314"/>
+      </p:ext>
+    </p:extLst>
+  </p:cSld>
+  <p:clrMapOvr>
+    <a:masterClrMapping/>
+  </p:clrMapOvr>
+</p:sld>
+</file>
+
+<file path=ppt/slides/slide6.xml><?xml version="1.0" encoding="utf-8"?>
+<p:sld xmlns:a="http://schemas.openxmlformats.org/drawingml/2006/main" xmlns:r="http://schemas.openxmlformats.org/officeDocument/2006/relationships" xmlns:p="http://schemas.openxmlformats.org/presentationml/2006/main">
+  <p:cSld>
+    <p:spTree>
+      <p:nvGrpSpPr>
+        <p:cNvPr id="1" name=""/>
+        <p:cNvGrpSpPr/>
+        <p:nvPr/>
+      </p:nvGrpSpPr>
+      <p:grpSpPr>
+        <a:xfrm>
+          <a:off x="0" y="0"/>
+          <a:ext cx="0" cy="0"/>
+          <a:chOff x="0" y="0"/>
+          <a:chExt cx="0" cy="0"/>
+        </a:xfrm>
+      </p:grpSpPr>
+      <p:sp>
+        <p:nvSpPr>
+          <p:cNvPr id="2" name="Title 1">
+            <a:extLst>
+              <a:ext uri="{FF2B5EF4-FFF2-40B4-BE49-F238E27FC236}">
+                <a16:creationId xmlns:a16="http://schemas.microsoft.com/office/drawing/2014/main" id="{88D5C618-F03E-EA92-CAEB-516FEDC4153F}"/>
+              </a:ext>
+            </a:extLst>
+          </p:cNvPr>
+          <p:cNvSpPr>
+            <a:spLocks noGrp="1"/>
+          </p:cNvSpPr>
+          <p:nvPr>
+            <p:ph type="title"/>
+          </p:nvPr>
+        </p:nvSpPr>
+        <p:spPr/>
+        <p:txBody>
+          <a:bodyPr/>
+          <a:lstStyle/>
+          <a:p>
+            <a:r>
+              <a:rPr lang="en-US"/>
+              <a:t>C Code Generation</a:t>
+            </a:r>
+            <a:endParaRPr lang="en-US" dirty="0"/>
+          </a:p>
+        </p:txBody>
+      </p:sp>
+      <p:sp>
+        <p:nvSpPr>
+          <p:cNvPr id="3" name="Slide Number Placeholder 2">
+            <a:extLst>
+              <a:ext uri="{FF2B5EF4-FFF2-40B4-BE49-F238E27FC236}">
+                <a16:creationId xmlns:a16="http://schemas.microsoft.com/office/drawing/2014/main" id="{BFA39D36-0A8B-32C6-2137-D0867231D7B0}"/>
+              </a:ext>
+            </a:extLst>
+          </p:cNvPr>
+          <p:cNvSpPr>
+            <a:spLocks noGrp="1"/>
+          </p:cNvSpPr>
+          <p:nvPr>
+            <p:ph type="sldNum" sz="quarter" idx="10"/>
+          </p:nvPr>
+        </p:nvSpPr>
+        <p:spPr/>
+        <p:txBody>
+          <a:bodyPr/>
+          <a:lstStyle/>
+          <a:p>
+            <a:fld id="{A241CA56-04D4-487E-9E31-9A10C01A108A}" type="slidenum">
+              <a:rPr lang="en-US" smtClean="0"/>
+              <a:pPr/>
+              <a:t>6</a:t>
+            </a:fld>
+            <a:endParaRPr lang="en-US" dirty="0"/>
+          </a:p>
+        </p:txBody>
+      </p:sp>
+      <p:sp>
+        <p:nvSpPr>
+          <p:cNvPr id="4" name="Content Placeholder 3">
+            <a:extLst>
+              <a:ext uri="{FF2B5EF4-FFF2-40B4-BE49-F238E27FC236}">
+                <a16:creationId xmlns:a16="http://schemas.microsoft.com/office/drawing/2014/main" id="{62EB3514-6148-6E08-9B86-E03EA5851AEC}"/>
+              </a:ext>
+            </a:extLst>
+          </p:cNvPr>
+          <p:cNvSpPr>
+            <a:spLocks noGrp="1"/>
+          </p:cNvSpPr>
+          <p:nvPr>
+            <p:ph idx="1"/>
+          </p:nvPr>
+        </p:nvSpPr>
+        <p:spPr/>
+        <p:txBody>
+          <a:bodyPr/>
+          <a:lstStyle/>
+          <a:p>
+            <a:r>
+              <a:rPr lang="en-US" dirty="0" err="1"/>
+              <a:t>Pwrcell_t</a:t>
+            </a:r>
+            <a:r>
+              <a:rPr lang="en-US" dirty="0"/>
+              <a:t> scaffolding (reference: </a:t>
+            </a:r>
+            <a:r>
+              <a:rPr lang="en-US" dirty="0" err="1"/>
+              <a:t>pwrcell.c</a:t>
+            </a:r>
+            <a:r>
+              <a:rPr lang="en-US" dirty="0"/>
+              <a:t>/h)</a:t>
+            </a:r>
+          </a:p>
+        </p:txBody>
+      </p:sp>
+      <p:pic>
+        <p:nvPicPr>
+          <p:cNvPr id="5" name="Picture 4" descr="demo_c_excerpt.png">
+            <a:extLst>
+              <a:ext uri="{FF2B5EF4-FFF2-40B4-BE49-F238E27FC236}">
+                <a16:creationId xmlns:a16="http://schemas.microsoft.com/office/drawing/2014/main" id="{AA7AE4CF-5392-C371-6EF8-924E79F873FE}"/>
+              </a:ext>
+            </a:extLst>
+          </p:cNvPr>
+          <p:cNvPicPr>
+            <a:picLocks noChangeAspect="1"/>
+          </p:cNvPicPr>
+          <p:nvPr/>
+        </p:nvPicPr>
+        <p:blipFill>
+          <a:blip r:embed="rId2"/>
+          <a:stretch>
+            <a:fillRect/>
+          </a:stretch>
+        </p:blipFill>
+        <p:spPr>
+          <a:xfrm>
+            <a:off x="1455563" y="975578"/>
+            <a:ext cx="6228392" cy="3572231"/>
           </a:xfrm>
           <a:prstGeom prst="rect">
             <a:avLst/>
@@ -4728,7 +5162,330 @@
     </p:spTree>
     <p:extLst>
       <p:ext uri="{BB962C8B-B14F-4D97-AF65-F5344CB8AC3E}">
-        <p14:creationId xmlns:p14="http://schemas.microsoft.com/office/powerpoint/2010/main" val="692366197"/>
+        <p14:creationId xmlns:p14="http://schemas.microsoft.com/office/powerpoint/2010/main" val="2358417163"/>
+      </p:ext>
+    </p:extLst>
+  </p:cSld>
+  <p:clrMapOvr>
+    <a:masterClrMapping/>
+  </p:clrMapOvr>
+</p:sld>
+</file>
+
+<file path=ppt/slides/slide7.xml><?xml version="1.0" encoding="utf-8"?>
+<p:sld xmlns:a="http://schemas.openxmlformats.org/drawingml/2006/main" xmlns:r="http://schemas.openxmlformats.org/officeDocument/2006/relationships" xmlns:p="http://schemas.openxmlformats.org/presentationml/2006/main">
+  <p:cSld>
+    <p:spTree>
+      <p:nvGrpSpPr>
+        <p:cNvPr id="1" name=""/>
+        <p:cNvGrpSpPr/>
+        <p:nvPr/>
+      </p:nvGrpSpPr>
+      <p:grpSpPr>
+        <a:xfrm>
+          <a:off x="0" y="0"/>
+          <a:ext cx="0" cy="0"/>
+          <a:chOff x="0" y="0"/>
+          <a:chExt cx="0" cy="0"/>
+        </a:xfrm>
+      </p:grpSpPr>
+      <p:sp>
+        <p:nvSpPr>
+          <p:cNvPr id="2" name="Title 1">
+            <a:extLst>
+              <a:ext uri="{FF2B5EF4-FFF2-40B4-BE49-F238E27FC236}">
+                <a16:creationId xmlns:a16="http://schemas.microsoft.com/office/drawing/2014/main" id="{C36DD87F-773E-2D44-42B8-4C021418BE1A}"/>
+              </a:ext>
+            </a:extLst>
+          </p:cNvPr>
+          <p:cNvSpPr>
+            <a:spLocks noGrp="1"/>
+          </p:cNvSpPr>
+          <p:nvPr>
+            <p:ph type="title"/>
+          </p:nvPr>
+        </p:nvSpPr>
+        <p:spPr>
+          <a:xfrm>
+            <a:off x="236669" y="89257"/>
+            <a:ext cx="8686799" cy="402335"/>
+          </a:xfrm>
+        </p:spPr>
+        <p:txBody>
+          <a:bodyPr anchor="ctr">
+            <a:normAutofit/>
+          </a:bodyPr>
+          <a:lstStyle/>
+          <a:p>
+            <a:r>
+              <a:rPr lang="en-US" sz="2100"/>
+              <a:t>Provided </a:t>
+            </a:r>
+            <a:r>
+              <a:rPr lang="en-US" sz="2100" err="1"/>
+              <a:t>WaveDrom</a:t>
+            </a:r>
+            <a:r>
+              <a:rPr lang="en-US" sz="2100"/>
+              <a:t> Timing</a:t>
+            </a:r>
+          </a:p>
+        </p:txBody>
+      </p:sp>
+      <p:sp>
+        <p:nvSpPr>
+          <p:cNvPr id="4" name="Content Placeholder 3">
+            <a:extLst>
+              <a:ext uri="{FF2B5EF4-FFF2-40B4-BE49-F238E27FC236}">
+                <a16:creationId xmlns:a16="http://schemas.microsoft.com/office/drawing/2014/main" id="{1AD536A7-7BF6-388F-1461-93871DF3CD95}"/>
+              </a:ext>
+            </a:extLst>
+          </p:cNvPr>
+          <p:cNvSpPr>
+            <a:spLocks noGrp="1"/>
+          </p:cNvSpPr>
+          <p:nvPr>
+            <p:ph idx="1"/>
+          </p:nvPr>
+        </p:nvSpPr>
+        <p:spPr>
+          <a:xfrm>
+            <a:off x="228600" y="595691"/>
+            <a:ext cx="4245909" cy="4185860"/>
+          </a:xfrm>
+        </p:spPr>
+        <p:txBody>
+          <a:bodyPr>
+            <a:normAutofit/>
+          </a:bodyPr>
+          <a:lstStyle/>
+          <a:p>
+            <a:r>
+              <a:rPr lang="en-US" dirty="0"/>
+              <a:t>Simulated from dependency graph (not RTL cycle-accurate)</a:t>
+            </a:r>
+          </a:p>
+        </p:txBody>
+      </p:sp>
+      <p:pic>
+        <p:nvPicPr>
+          <p:cNvPr id="5" name="Picture 4" descr="demo_wavedrom_png.png">
+            <a:extLst>
+              <a:ext uri="{FF2B5EF4-FFF2-40B4-BE49-F238E27FC236}">
+                <a16:creationId xmlns:a16="http://schemas.microsoft.com/office/drawing/2014/main" id="{CF1E3F9D-3F9B-386F-660E-7B322DB96315}"/>
+              </a:ext>
+            </a:extLst>
+          </p:cNvPr>
+          <p:cNvPicPr>
+            <a:picLocks noChangeAspect="1"/>
+          </p:cNvPicPr>
+          <p:nvPr/>
+        </p:nvPicPr>
+        <p:blipFill>
+          <a:blip r:embed="rId2"/>
+          <a:srcRect l="5240" r="11585" b="2"/>
+          <a:stretch>
+            <a:fillRect/>
+          </a:stretch>
+        </p:blipFill>
+        <p:spPr>
+          <a:xfrm>
+            <a:off x="4665009" y="595691"/>
+            <a:ext cx="4245909" cy="4185860"/>
+          </a:xfrm>
+          <a:prstGeom prst="rect">
+            <a:avLst/>
+          </a:prstGeom>
+          <a:noFill/>
+        </p:spPr>
+      </p:pic>
+      <p:sp>
+        <p:nvSpPr>
+          <p:cNvPr id="3" name="Slide Number Placeholder 2">
+            <a:extLst>
+              <a:ext uri="{FF2B5EF4-FFF2-40B4-BE49-F238E27FC236}">
+                <a16:creationId xmlns:a16="http://schemas.microsoft.com/office/drawing/2014/main" id="{8C499031-D735-8FA4-4926-1CA115C98638}"/>
+              </a:ext>
+            </a:extLst>
+          </p:cNvPr>
+          <p:cNvSpPr>
+            <a:spLocks noGrp="1"/>
+          </p:cNvSpPr>
+          <p:nvPr>
+            <p:ph type="sldNum" sz="quarter" idx="10"/>
+          </p:nvPr>
+        </p:nvSpPr>
+        <p:spPr/>
+        <p:txBody>
+          <a:bodyPr/>
+          <a:lstStyle/>
+          <a:p>
+            <a:pPr>
+              <a:spcAft>
+                <a:spcPts val="600"/>
+              </a:spcAft>
+            </a:pPr>
+            <a:fld id="{A241CA56-04D4-487E-9E31-9A10C01A108A}" type="slidenum">
+              <a:rPr lang="en-US" smtClean="0"/>
+              <a:pPr>
+                <a:spcAft>
+                  <a:spcPts val="600"/>
+                </a:spcAft>
+              </a:pPr>
+              <a:t>7</a:t>
+            </a:fld>
+            <a:endParaRPr lang="en-US"/>
+          </a:p>
+        </p:txBody>
+      </p:sp>
+    </p:spTree>
+    <p:extLst>
+      <p:ext uri="{BB962C8B-B14F-4D97-AF65-F5344CB8AC3E}">
+        <p14:creationId xmlns:p14="http://schemas.microsoft.com/office/powerpoint/2010/main" val="3271740098"/>
+      </p:ext>
+    </p:extLst>
+  </p:cSld>
+  <p:clrMapOvr>
+    <a:masterClrMapping/>
+  </p:clrMapOvr>
+</p:sld>
+</file>
+
+<file path=ppt/slides/slide8.xml><?xml version="1.0" encoding="utf-8"?>
+<p:sld xmlns:a="http://schemas.openxmlformats.org/drawingml/2006/main" xmlns:r="http://schemas.openxmlformats.org/officeDocument/2006/relationships" xmlns:p="http://schemas.openxmlformats.org/presentationml/2006/main">
+  <p:cSld>
+    <p:spTree>
+      <p:nvGrpSpPr>
+        <p:cNvPr id="1" name=""/>
+        <p:cNvGrpSpPr/>
+        <p:nvPr/>
+      </p:nvGrpSpPr>
+      <p:grpSpPr>
+        <a:xfrm>
+          <a:off x="0" y="0"/>
+          <a:ext cx="0" cy="0"/>
+          <a:chOff x="0" y="0"/>
+          <a:chExt cx="0" cy="0"/>
+        </a:xfrm>
+      </p:grpSpPr>
+      <p:sp>
+        <p:nvSpPr>
+          <p:cNvPr id="2" name="Title 1">
+            <a:extLst>
+              <a:ext uri="{FF2B5EF4-FFF2-40B4-BE49-F238E27FC236}">
+                <a16:creationId xmlns:a16="http://schemas.microsoft.com/office/drawing/2014/main" id="{B811A830-B270-8E0E-79A3-4FC55BA6685E}"/>
+              </a:ext>
+            </a:extLst>
+          </p:cNvPr>
+          <p:cNvSpPr>
+            <a:spLocks noGrp="1"/>
+          </p:cNvSpPr>
+          <p:nvPr>
+            <p:ph type="title"/>
+          </p:nvPr>
+        </p:nvSpPr>
+        <p:spPr>
+          <a:xfrm>
+            <a:off x="236669" y="89257"/>
+            <a:ext cx="8686799" cy="402335"/>
+          </a:xfrm>
+        </p:spPr>
+        <p:txBody>
+          <a:bodyPr anchor="ctr">
+            <a:normAutofit/>
+          </a:bodyPr>
+          <a:lstStyle/>
+          <a:p>
+            <a:r>
+              <a:rPr lang="en-US" sz="2100"/>
+              <a:t>Tooling &amp; Quality</a:t>
+            </a:r>
+          </a:p>
+        </p:txBody>
+      </p:sp>
+      <p:pic>
+        <p:nvPicPr>
+          <p:cNvPr id="6" name="Content Placeholder 5">
+            <a:extLst>
+              <a:ext uri="{FF2B5EF4-FFF2-40B4-BE49-F238E27FC236}">
+                <a16:creationId xmlns:a16="http://schemas.microsoft.com/office/drawing/2014/main" id="{3B553F47-97B9-03D7-78A0-25DF8576F5C3}"/>
+              </a:ext>
+            </a:extLst>
+          </p:cNvPr>
+          <p:cNvPicPr>
+            <a:picLocks noGrp="1" noChangeAspect="1"/>
+          </p:cNvPicPr>
+          <p:nvPr>
+            <p:ph idx="1"/>
+          </p:nvPr>
+        </p:nvPicPr>
+        <p:blipFill>
+          <a:blip r:embed="rId2" cstate="print">
+            <a:extLst>
+              <a:ext uri="{28A0092B-C50C-407E-A947-70E740481C1C}">
+                <a14:useLocalDpi xmlns:a14="http://schemas.microsoft.com/office/drawing/2010/main" val="0"/>
+              </a:ext>
+            </a:extLst>
+          </a:blip>
+          <a:srcRect t="15380" b="46413"/>
+          <a:stretch>
+            <a:fillRect/>
+          </a:stretch>
+        </p:blipFill>
+        <p:spPr>
+          <a:xfrm>
+            <a:off x="228600" y="595691"/>
+            <a:ext cx="8682318" cy="4185860"/>
+          </a:xfrm>
+          <a:prstGeom prst="rect">
+            <a:avLst/>
+          </a:prstGeom>
+          <a:noFill/>
+        </p:spPr>
+      </p:pic>
+      <p:sp>
+        <p:nvSpPr>
+          <p:cNvPr id="3" name="Slide Number Placeholder 2">
+            <a:extLst>
+              <a:ext uri="{FF2B5EF4-FFF2-40B4-BE49-F238E27FC236}">
+                <a16:creationId xmlns:a16="http://schemas.microsoft.com/office/drawing/2014/main" id="{8D504C4F-9CE8-E6C3-BCEA-4AAC89D4F2C2}"/>
+              </a:ext>
+            </a:extLst>
+          </p:cNvPr>
+          <p:cNvSpPr>
+            <a:spLocks noGrp="1"/>
+          </p:cNvSpPr>
+          <p:nvPr>
+            <p:ph type="sldNum" sz="quarter" idx="10"/>
+          </p:nvPr>
+        </p:nvSpPr>
+        <p:spPr/>
+        <p:txBody>
+          <a:bodyPr/>
+          <a:lstStyle/>
+          <a:p>
+            <a:pPr>
+              <a:spcAft>
+                <a:spcPts val="600"/>
+              </a:spcAft>
+            </a:pPr>
+            <a:fld id="{A241CA56-04D4-487E-9E31-9A10C01A108A}" type="slidenum">
+              <a:rPr lang="en-US" smtClean="0"/>
+              <a:pPr>
+                <a:spcAft>
+                  <a:spcPts val="600"/>
+                </a:spcAft>
+              </a:pPr>
+              <a:t>8</a:t>
+            </a:fld>
+            <a:endParaRPr lang="en-US"/>
+          </a:p>
+        </p:txBody>
+      </p:sp>
+    </p:spTree>
+    <p:extLst>
+      <p:ext uri="{BB962C8B-B14F-4D97-AF65-F5344CB8AC3E}">
+        <p14:creationId xmlns:p14="http://schemas.microsoft.com/office/powerpoint/2010/main" val="3177945485"/>
       </p:ext>
     </p:extLst>
   </p:cSld>

</xml_diff>

<commit_message>
Polish left-panel GUI and Draw.io deb labels for export.
Move node add/delete under the list, unify Timing Signals styling, fix preview pane toggle and paned sash UX, drop WaveDrom from preview, and label PSEQCELL ports as H:/L: times.

Co-authored-by: Cursor <cursoragent@cursor.com>
</commit_message>
<xml_diff>
--- a/doc/PowerSequenceGenerator_v1.3.pptx
+++ b/doc/PowerSequenceGenerator_v1.3.pptx
@@ -5,25 +5,26 @@
     <p:sldMasterId id="2147483663" r:id="rId1"/>
   </p:sldMasterIdLst>
   <p:notesMasterIdLst>
-    <p:notesMasterId r:id="rId10"/>
+    <p:notesMasterId r:id="rId11"/>
   </p:notesMasterIdLst>
   <p:handoutMasterIdLst>
-    <p:handoutMasterId r:id="rId11"/>
+    <p:handoutMasterId r:id="rId12"/>
   </p:handoutMasterIdLst>
   <p:sldIdLst>
     <p:sldId id="256" r:id="rId2"/>
     <p:sldId id="258" r:id="rId3"/>
-    <p:sldId id="259" r:id="rId4"/>
-    <p:sldId id="260" r:id="rId5"/>
-    <p:sldId id="261" r:id="rId6"/>
-    <p:sldId id="262" r:id="rId7"/>
-    <p:sldId id="263" r:id="rId8"/>
-    <p:sldId id="264" r:id="rId9"/>
+    <p:sldId id="265" r:id="rId4"/>
+    <p:sldId id="259" r:id="rId5"/>
+    <p:sldId id="260" r:id="rId6"/>
+    <p:sldId id="261" r:id="rId7"/>
+    <p:sldId id="262" r:id="rId8"/>
+    <p:sldId id="263" r:id="rId9"/>
+    <p:sldId id="264" r:id="rId10"/>
   </p:sldIdLst>
   <p:sldSz cx="9144000" cy="5143500" type="screen16x9"/>
   <p:notesSz cx="6662738" cy="9926638"/>
   <p:custDataLst>
-    <p:tags r:id="rId12"/>
+    <p:tags r:id="rId13"/>
   </p:custDataLst>
   <p:defaultTextStyle>
     <a:defPPr>
@@ -252,7 +253,7 @@
             <a:fld id="{AD20BEF9-AA05-4FF8-873E-9941013038D7}" type="datetimeFigureOut">
               <a:rPr lang="zh-TW" altLang="en-US" smtClean="0"/>
               <a:pPr/>
-              <a:t>2026/6/8</a:t>
+              <a:t>2026/6/9</a:t>
             </a:fld>
             <a:endParaRPr lang="zh-TW" altLang="en-US"/>
           </a:p>
@@ -418,7 +419,7 @@
           <a:p>
             <a:fld id="{B5828AD7-229D-4E70-BA7E-76E0859339A6}" type="datetimeFigureOut">
               <a:rPr lang="en-US" smtClean="0"/>
-              <a:t>6/8/2026</a:t>
+              <a:t>6/9/2026</a:t>
             </a:fld>
             <a:endParaRPr lang="en-US"/>
           </a:p>
@@ -4439,7 +4440,7 @@
           <p:cNvPr id="2" name="Title 1">
             <a:extLst>
               <a:ext uri="{FF2B5EF4-FFF2-40B4-BE49-F238E27FC236}">
-                <a16:creationId xmlns:a16="http://schemas.microsoft.com/office/drawing/2014/main" id="{09A0E406-6580-0134-DDC2-F8FC53A28051}"/>
+                <a16:creationId xmlns:a16="http://schemas.microsoft.com/office/drawing/2014/main" id="{EC7B7AFD-D2DA-0FE1-A137-3769A6D4C773}"/>
               </a:ext>
             </a:extLst>
           </p:cNvPr>
@@ -4457,7 +4458,7 @@
           <a:p>
             <a:r>
               <a:rPr lang="en-US" dirty="0"/>
-              <a:t>Configuration model</a:t>
+              <a:t>UI</a:t>
             </a:r>
           </a:p>
         </p:txBody>
@@ -4467,7 +4468,7 @@
           <p:cNvPr id="3" name="Slide Number Placeholder 2">
             <a:extLst>
               <a:ext uri="{FF2B5EF4-FFF2-40B4-BE49-F238E27FC236}">
-                <a16:creationId xmlns:a16="http://schemas.microsoft.com/office/drawing/2014/main" id="{32013706-4836-B787-0F19-BAFDAD1DD48A}"/>
+                <a16:creationId xmlns:a16="http://schemas.microsoft.com/office/drawing/2014/main" id="{41128375-5FC5-2F78-1AA1-DAED95539BB6}"/>
               </a:ext>
             </a:extLst>
           </p:cNvPr>
@@ -4497,7 +4498,7 @@
           <p:cNvPr id="4" name="Content Placeholder 3">
             <a:extLst>
               <a:ext uri="{FF2B5EF4-FFF2-40B4-BE49-F238E27FC236}">
-                <a16:creationId xmlns:a16="http://schemas.microsoft.com/office/drawing/2014/main" id="{6B709AC2-0379-0C20-808D-9C96603CECD9}"/>
+                <a16:creationId xmlns:a16="http://schemas.microsoft.com/office/drawing/2014/main" id="{70D32C05-FB5E-6403-EC14-050F531DB9B4}"/>
               </a:ext>
             </a:extLst>
           </p:cNvPr>
@@ -4514,46 +4515,30 @@
           <a:lstStyle/>
           <a:p>
             <a:r>
+              <a:rPr lang="en-US" altLang="zh-TW" dirty="0"/>
+              <a:t>Signals Declare Area: declare input/output and timing signals.</a:t>
+            </a:r>
+          </a:p>
+          <a:p>
+            <a:r>
               <a:rPr lang="en-US" dirty="0"/>
-              <a:t>Rails, conditions, validation</a:t>
-            </a:r>
-          </a:p>
-          <a:p>
-            <a:pPr lvl="1"/>
+              <a:t>Nodes Configuration Area: Configurate input/output behavior.</a:t>
+            </a:r>
+          </a:p>
+          <a:p>
             <a:r>
               <a:rPr lang="en-US" dirty="0"/>
-              <a:t>Node = Input (debounce) or Output (PSEQCELL).</a:t>
-            </a:r>
-          </a:p>
-          <a:p>
-            <a:pPr lvl="1"/>
-            <a:r>
-              <a:rPr lang="en-US" dirty="0"/>
-              <a:t>Hi / Lo Force: AND inside group, OR across groups.</a:t>
-            </a:r>
-          </a:p>
-          <a:p>
-            <a:pPr lvl="1"/>
-            <a:r>
-              <a:rPr lang="en-US" dirty="0"/>
-              <a:t>Invert &amp; use-mode (node / Hi / Lo / self feedback).</a:t>
-            </a:r>
-          </a:p>
-          <a:p>
-            <a:pPr lvl="1"/>
-            <a:r>
-              <a:rPr lang="en-US" dirty="0"/>
-              <a:t>Timing: CYCLE_*, RECOVER, INIT, FORCE, OD.</a:t>
+              <a:t>Output Preview Area: Preview Verilog, C Language, and Wave Drom code.</a:t>
             </a:r>
           </a:p>
         </p:txBody>
       </p:sp>
       <p:pic>
         <p:nvPicPr>
-          <p:cNvPr id="6" name="Picture 5">
+          <p:cNvPr id="8" name="Picture 7">
             <a:extLst>
               <a:ext uri="{FF2B5EF4-FFF2-40B4-BE49-F238E27FC236}">
-                <a16:creationId xmlns:a16="http://schemas.microsoft.com/office/drawing/2014/main" id="{ABC0D690-F9A7-37B7-52A2-0FD481ABF5BA}"/>
+                <a16:creationId xmlns:a16="http://schemas.microsoft.com/office/drawing/2014/main" id="{AE1C3217-98EB-8245-12B2-D3FC039E2079}"/>
               </a:ext>
             </a:extLst>
           </p:cNvPr>
@@ -4570,38 +4555,8 @@
         </p:blipFill>
         <p:spPr>
           <a:xfrm>
-            <a:off x="609600" y="2038350"/>
-            <a:ext cx="3268531" cy="1520371"/>
-          </a:xfrm>
-          <a:prstGeom prst="rect">
-            <a:avLst/>
-          </a:prstGeom>
-        </p:spPr>
-      </p:pic>
-      <p:pic>
-        <p:nvPicPr>
-          <p:cNvPr id="8" name="Picture 7">
-            <a:extLst>
-              <a:ext uri="{FF2B5EF4-FFF2-40B4-BE49-F238E27FC236}">
-                <a16:creationId xmlns:a16="http://schemas.microsoft.com/office/drawing/2014/main" id="{4CF388F3-A6D9-46AA-F376-3B58C34FACF6}"/>
-              </a:ext>
-            </a:extLst>
-          </p:cNvPr>
-          <p:cNvPicPr>
-            <a:picLocks noChangeAspect="1"/>
-          </p:cNvPicPr>
-          <p:nvPr/>
-        </p:nvPicPr>
-        <p:blipFill>
-          <a:blip r:embed="rId3"/>
-          <a:stretch>
-            <a:fillRect/>
-          </a:stretch>
-        </p:blipFill>
-        <p:spPr>
-          <a:xfrm>
-            <a:off x="4704529" y="2038350"/>
-            <a:ext cx="3007059" cy="2488099"/>
+            <a:off x="4114800" y="1685832"/>
+            <a:ext cx="4893268" cy="3112403"/>
           </a:xfrm>
           <a:prstGeom prst="rect">
             <a:avLst/>
@@ -4611,7 +4566,7 @@
     </p:spTree>
     <p:extLst>
       <p:ext uri="{BB962C8B-B14F-4D97-AF65-F5344CB8AC3E}">
-        <p14:creationId xmlns:p14="http://schemas.microsoft.com/office/powerpoint/2010/main" val="2434528151"/>
+        <p14:creationId xmlns:p14="http://schemas.microsoft.com/office/powerpoint/2010/main" val="3227356277"/>
       </p:ext>
     </p:extLst>
   </p:cSld>
@@ -4643,6 +4598,247 @@
           <p:cNvPr id="2" name="Title 1">
             <a:extLst>
               <a:ext uri="{FF2B5EF4-FFF2-40B4-BE49-F238E27FC236}">
+                <a16:creationId xmlns:a16="http://schemas.microsoft.com/office/drawing/2014/main" id="{09A0E406-6580-0134-DDC2-F8FC53A28051}"/>
+              </a:ext>
+            </a:extLst>
+          </p:cNvPr>
+          <p:cNvSpPr>
+            <a:spLocks noGrp="1"/>
+          </p:cNvSpPr>
+          <p:nvPr>
+            <p:ph type="title"/>
+          </p:nvPr>
+        </p:nvSpPr>
+        <p:spPr/>
+        <p:txBody>
+          <a:bodyPr/>
+          <a:lstStyle/>
+          <a:p>
+            <a:r>
+              <a:rPr lang="en-US" dirty="0"/>
+              <a:t>Configuration model</a:t>
+            </a:r>
+          </a:p>
+        </p:txBody>
+      </p:sp>
+      <p:sp>
+        <p:nvSpPr>
+          <p:cNvPr id="3" name="Slide Number Placeholder 2">
+            <a:extLst>
+              <a:ext uri="{FF2B5EF4-FFF2-40B4-BE49-F238E27FC236}">
+                <a16:creationId xmlns:a16="http://schemas.microsoft.com/office/drawing/2014/main" id="{32013706-4836-B787-0F19-BAFDAD1DD48A}"/>
+              </a:ext>
+            </a:extLst>
+          </p:cNvPr>
+          <p:cNvSpPr>
+            <a:spLocks noGrp="1"/>
+          </p:cNvSpPr>
+          <p:nvPr>
+            <p:ph type="sldNum" sz="quarter" idx="10"/>
+          </p:nvPr>
+        </p:nvSpPr>
+        <p:spPr/>
+        <p:txBody>
+          <a:bodyPr/>
+          <a:lstStyle/>
+          <a:p>
+            <a:fld id="{A241CA56-04D4-487E-9E31-9A10C01A108A}" type="slidenum">
+              <a:rPr lang="en-US" smtClean="0"/>
+              <a:pPr/>
+              <a:t>4</a:t>
+            </a:fld>
+            <a:endParaRPr lang="en-US" dirty="0"/>
+          </a:p>
+        </p:txBody>
+      </p:sp>
+      <p:sp>
+        <p:nvSpPr>
+          <p:cNvPr id="4" name="Content Placeholder 3">
+            <a:extLst>
+              <a:ext uri="{FF2B5EF4-FFF2-40B4-BE49-F238E27FC236}">
+                <a16:creationId xmlns:a16="http://schemas.microsoft.com/office/drawing/2014/main" id="{6B709AC2-0379-0C20-808D-9C96603CECD9}"/>
+              </a:ext>
+            </a:extLst>
+          </p:cNvPr>
+          <p:cNvSpPr>
+            <a:spLocks noGrp="1"/>
+          </p:cNvSpPr>
+          <p:nvPr>
+            <p:ph idx="1"/>
+          </p:nvPr>
+        </p:nvSpPr>
+        <p:spPr/>
+        <p:txBody>
+          <a:bodyPr/>
+          <a:lstStyle/>
+          <a:p>
+            <a:r>
+              <a:rPr lang="en-US" dirty="0"/>
+              <a:t>Input</a:t>
+            </a:r>
+          </a:p>
+          <a:p>
+            <a:pPr lvl="1"/>
+            <a:r>
+              <a:rPr lang="en-US" dirty="0"/>
+              <a:t>Debounce: </a:t>
+            </a:r>
+          </a:p>
+          <a:p>
+            <a:pPr lvl="2"/>
+            <a:r>
+              <a:rPr lang="en-US" dirty="0"/>
+              <a:t>Enable Debounce or Not</a:t>
+            </a:r>
+          </a:p>
+          <a:p>
+            <a:pPr lvl="2"/>
+            <a:r>
+              <a:rPr lang="en-US" dirty="0"/>
+              <a:t>CYCLE_*: Debounce cycle.</a:t>
+            </a:r>
+          </a:p>
+          <a:p>
+            <a:pPr lvl="2"/>
+            <a:r>
+              <a:rPr lang="en-US" dirty="0"/>
+              <a:t>Timing Deb: Debounce Timing Signals</a:t>
+            </a:r>
+          </a:p>
+          <a:p>
+            <a:pPr lvl="2"/>
+            <a:r>
+              <a:rPr lang="en-US" dirty="0"/>
+              <a:t>INIT: Initial level</a:t>
+            </a:r>
+          </a:p>
+          <a:p>
+            <a:r>
+              <a:rPr lang="en-US" dirty="0"/>
+              <a:t>Output</a:t>
+            </a:r>
+          </a:p>
+          <a:p>
+            <a:pPr lvl="1"/>
+            <a:r>
+              <a:rPr lang="en-US" dirty="0"/>
+              <a:t>CYCLE_*: Delay cycle for condition asserted.</a:t>
+            </a:r>
+          </a:p>
+          <a:p>
+            <a:pPr lvl="1"/>
+            <a:r>
+              <a:rPr lang="en-US" dirty="0"/>
+              <a:t>INIT: Initial level</a:t>
+            </a:r>
+          </a:p>
+          <a:p>
+            <a:pPr lvl="1"/>
+            <a:r>
+              <a:rPr lang="en-US" dirty="0"/>
+              <a:t>Timing *: Delay Timing Signals.</a:t>
+            </a:r>
+          </a:p>
+          <a:p>
+            <a:endParaRPr lang="en-US" dirty="0"/>
+          </a:p>
+        </p:txBody>
+      </p:sp>
+      <p:pic>
+        <p:nvPicPr>
+          <p:cNvPr id="7" name="Picture 6">
+            <a:extLst>
+              <a:ext uri="{FF2B5EF4-FFF2-40B4-BE49-F238E27FC236}">
+                <a16:creationId xmlns:a16="http://schemas.microsoft.com/office/drawing/2014/main" id="{409BEAEF-A7FB-F67D-F66E-E67815B7883B}"/>
+              </a:ext>
+            </a:extLst>
+          </p:cNvPr>
+          <p:cNvPicPr>
+            <a:picLocks noChangeAspect="1"/>
+          </p:cNvPicPr>
+          <p:nvPr/>
+        </p:nvPicPr>
+        <p:blipFill>
+          <a:blip r:embed="rId2"/>
+          <a:stretch>
+            <a:fillRect/>
+          </a:stretch>
+        </p:blipFill>
+        <p:spPr>
+          <a:xfrm>
+            <a:off x="6354325" y="1717273"/>
+            <a:ext cx="2566362" cy="3085275"/>
+          </a:xfrm>
+          <a:prstGeom prst="rect">
+            <a:avLst/>
+          </a:prstGeom>
+        </p:spPr>
+      </p:pic>
+      <p:pic>
+        <p:nvPicPr>
+          <p:cNvPr id="10" name="Picture 9">
+            <a:extLst>
+              <a:ext uri="{FF2B5EF4-FFF2-40B4-BE49-F238E27FC236}">
+                <a16:creationId xmlns:a16="http://schemas.microsoft.com/office/drawing/2014/main" id="{186F31CF-E835-5CA4-0D6A-BAE3C30F2186}"/>
+              </a:ext>
+            </a:extLst>
+          </p:cNvPr>
+          <p:cNvPicPr>
+            <a:picLocks noChangeAspect="1"/>
+          </p:cNvPicPr>
+          <p:nvPr/>
+        </p:nvPicPr>
+        <p:blipFill>
+          <a:blip r:embed="rId3"/>
+          <a:stretch>
+            <a:fillRect/>
+          </a:stretch>
+        </p:blipFill>
+        <p:spPr>
+          <a:xfrm>
+            <a:off x="3761371" y="3157713"/>
+            <a:ext cx="2561815" cy="1644835"/>
+          </a:xfrm>
+          <a:prstGeom prst="rect">
+            <a:avLst/>
+          </a:prstGeom>
+        </p:spPr>
+      </p:pic>
+    </p:spTree>
+    <p:extLst>
+      <p:ext uri="{BB962C8B-B14F-4D97-AF65-F5344CB8AC3E}">
+        <p14:creationId xmlns:p14="http://schemas.microsoft.com/office/powerpoint/2010/main" val="2434528151"/>
+      </p:ext>
+    </p:extLst>
+  </p:cSld>
+  <p:clrMapOvr>
+    <a:masterClrMapping/>
+  </p:clrMapOvr>
+</p:sld>
+</file>
+
+<file path=ppt/slides/slide5.xml><?xml version="1.0" encoding="utf-8"?>
+<p:sld xmlns:a="http://schemas.openxmlformats.org/drawingml/2006/main" xmlns:r="http://schemas.openxmlformats.org/officeDocument/2006/relationships" xmlns:p="http://schemas.openxmlformats.org/presentationml/2006/main">
+  <p:cSld>
+    <p:spTree>
+      <p:nvGrpSpPr>
+        <p:cNvPr id="1" name=""/>
+        <p:cNvGrpSpPr/>
+        <p:nvPr/>
+      </p:nvGrpSpPr>
+      <p:grpSpPr>
+        <a:xfrm>
+          <a:off x="0" y="0"/>
+          <a:ext cx="0" cy="0"/>
+          <a:chOff x="0" y="0"/>
+          <a:chExt cx="0" cy="0"/>
+        </a:xfrm>
+      </p:grpSpPr>
+      <p:sp>
+        <p:nvSpPr>
+          <p:cNvPr id="2" name="Title 1">
+            <a:extLst>
+              <a:ext uri="{FF2B5EF4-FFF2-40B4-BE49-F238E27FC236}">
                 <a16:creationId xmlns:a16="http://schemas.microsoft.com/office/drawing/2014/main" id="{13C5DC66-08A3-3DF9-1CE9-2DBD5547BA92}"/>
               </a:ext>
             </a:extLst>
@@ -4690,7 +4886,7 @@
             <a:fld id="{A241CA56-04D4-487E-9E31-9A10C01A108A}" type="slidenum">
               <a:rPr lang="en-US" smtClean="0"/>
               <a:pPr/>
-              <a:t>4</a:t>
+              <a:t>5</a:t>
             </a:fld>
             <a:endParaRPr lang="en-US" dirty="0"/>
           </a:p>
@@ -4843,176 +5039,6 @@
 </p:sld>
 </file>
 
-<file path=ppt/slides/slide5.xml><?xml version="1.0" encoding="utf-8"?>
-<p:sld xmlns:a="http://schemas.openxmlformats.org/drawingml/2006/main" xmlns:r="http://schemas.openxmlformats.org/officeDocument/2006/relationships" xmlns:p="http://schemas.openxmlformats.org/presentationml/2006/main">
-  <p:cSld>
-    <p:spTree>
-      <p:nvGrpSpPr>
-        <p:cNvPr id="1" name=""/>
-        <p:cNvGrpSpPr/>
-        <p:nvPr/>
-      </p:nvGrpSpPr>
-      <p:grpSpPr>
-        <a:xfrm>
-          <a:off x="0" y="0"/>
-          <a:ext cx="0" cy="0"/>
-          <a:chOff x="0" y="0"/>
-          <a:chExt cx="0" cy="0"/>
-        </a:xfrm>
-      </p:grpSpPr>
-      <p:sp>
-        <p:nvSpPr>
-          <p:cNvPr id="2" name="Title 1">
-            <a:extLst>
-              <a:ext uri="{FF2B5EF4-FFF2-40B4-BE49-F238E27FC236}">
-                <a16:creationId xmlns:a16="http://schemas.microsoft.com/office/drawing/2014/main" id="{C3648DAC-BE93-31A0-D0B9-F20BB1606568}"/>
-              </a:ext>
-            </a:extLst>
-          </p:cNvPr>
-          <p:cNvSpPr>
-            <a:spLocks noGrp="1"/>
-          </p:cNvSpPr>
-          <p:nvPr>
-            <p:ph type="title"/>
-          </p:nvPr>
-        </p:nvSpPr>
-        <p:spPr>
-          <a:xfrm>
-            <a:off x="236669" y="89257"/>
-            <a:ext cx="8686799" cy="402335"/>
-          </a:xfrm>
-        </p:spPr>
-        <p:txBody>
-          <a:bodyPr anchor="ctr">
-            <a:normAutofit/>
-          </a:bodyPr>
-          <a:lstStyle/>
-          <a:p>
-            <a:r>
-              <a:rPr lang="en-US" sz="2100"/>
-              <a:t>Verilog Generation</a:t>
-            </a:r>
-          </a:p>
-        </p:txBody>
-      </p:sp>
-      <p:sp>
-        <p:nvSpPr>
-          <p:cNvPr id="4" name="Content Placeholder 3">
-            <a:extLst>
-              <a:ext uri="{FF2B5EF4-FFF2-40B4-BE49-F238E27FC236}">
-                <a16:creationId xmlns:a16="http://schemas.microsoft.com/office/drawing/2014/main" id="{CFBE5B1C-0CCE-274E-A635-DE186842EDA0}"/>
-              </a:ext>
-            </a:extLst>
-          </p:cNvPr>
-          <p:cNvSpPr>
-            <a:spLocks noGrp="1"/>
-          </p:cNvSpPr>
-          <p:nvPr>
-            <p:ph idx="1"/>
-          </p:nvPr>
-        </p:nvSpPr>
-        <p:spPr>
-          <a:xfrm>
-            <a:off x="228600" y="595691"/>
-            <a:ext cx="4245909" cy="4185860"/>
-          </a:xfrm>
-        </p:spPr>
-        <p:txBody>
-          <a:bodyPr>
-            <a:normAutofit/>
-          </a:bodyPr>
-          <a:lstStyle/>
-          <a:p>
-            <a:r>
-              <a:rPr lang="en-US" dirty="0"/>
-              <a:t>Auto-generated module + PSEQCELL instances</a:t>
-            </a:r>
-          </a:p>
-        </p:txBody>
-      </p:sp>
-      <p:pic>
-        <p:nvPicPr>
-          <p:cNvPr id="5" name="Picture 4" descr="demo_verilog_excerpt.png">
-            <a:extLst>
-              <a:ext uri="{FF2B5EF4-FFF2-40B4-BE49-F238E27FC236}">
-                <a16:creationId xmlns:a16="http://schemas.microsoft.com/office/drawing/2014/main" id="{DA02F18A-319E-5CED-0577-CC4065611991}"/>
-              </a:ext>
-            </a:extLst>
-          </p:cNvPr>
-          <p:cNvPicPr>
-            <a:picLocks noChangeAspect="1"/>
-          </p:cNvPicPr>
-          <p:nvPr/>
-        </p:nvPicPr>
-        <p:blipFill>
-          <a:blip r:embed="rId2"/>
-          <a:stretch>
-            <a:fillRect/>
-          </a:stretch>
-        </p:blipFill>
-        <p:spPr>
-          <a:xfrm>
-            <a:off x="4665009" y="1473229"/>
-            <a:ext cx="4245909" cy="2430783"/>
-          </a:xfrm>
-          <a:prstGeom prst="rect">
-            <a:avLst/>
-          </a:prstGeom>
-          <a:noFill/>
-        </p:spPr>
-      </p:pic>
-      <p:sp>
-        <p:nvSpPr>
-          <p:cNvPr id="3" name="Slide Number Placeholder 2">
-            <a:extLst>
-              <a:ext uri="{FF2B5EF4-FFF2-40B4-BE49-F238E27FC236}">
-                <a16:creationId xmlns:a16="http://schemas.microsoft.com/office/drawing/2014/main" id="{F7C76006-54E2-B092-FAA0-91B5E38E2CC0}"/>
-              </a:ext>
-            </a:extLst>
-          </p:cNvPr>
-          <p:cNvSpPr>
-            <a:spLocks noGrp="1"/>
-          </p:cNvSpPr>
-          <p:nvPr>
-            <p:ph type="sldNum" sz="quarter" idx="10"/>
-          </p:nvPr>
-        </p:nvSpPr>
-        <p:spPr/>
-        <p:txBody>
-          <a:bodyPr/>
-          <a:lstStyle/>
-          <a:p>
-            <a:pPr>
-              <a:spcAft>
-                <a:spcPts val="600"/>
-              </a:spcAft>
-            </a:pPr>
-            <a:fld id="{A241CA56-04D4-487E-9E31-9A10C01A108A}" type="slidenum">
-              <a:rPr lang="en-US" smtClean="0"/>
-              <a:pPr>
-                <a:spcAft>
-                  <a:spcPts val="600"/>
-                </a:spcAft>
-              </a:pPr>
-              <a:t>5</a:t>
-            </a:fld>
-            <a:endParaRPr lang="en-US"/>
-          </a:p>
-        </p:txBody>
-      </p:sp>
-    </p:spTree>
-    <p:extLst>
-      <p:ext uri="{BB962C8B-B14F-4D97-AF65-F5344CB8AC3E}">
-        <p14:creationId xmlns:p14="http://schemas.microsoft.com/office/powerpoint/2010/main" val="1665871314"/>
-      </p:ext>
-    </p:extLst>
-  </p:cSld>
-  <p:clrMapOvr>
-    <a:masterClrMapping/>
-  </p:clrMapOvr>
-</p:sld>
-</file>
-
 <file path=ppt/slides/slide6.xml><?xml version="1.0" encoding="utf-8"?>
 <p:sld xmlns:a="http://schemas.openxmlformats.org/drawingml/2006/main" xmlns:r="http://schemas.openxmlformats.org/officeDocument/2006/relationships" xmlns:p="http://schemas.openxmlformats.org/presentationml/2006/main">
   <p:cSld>
@@ -5035,7 +5061,7 @@
           <p:cNvPr id="2" name="Title 1">
             <a:extLst>
               <a:ext uri="{FF2B5EF4-FFF2-40B4-BE49-F238E27FC236}">
-                <a16:creationId xmlns:a16="http://schemas.microsoft.com/office/drawing/2014/main" id="{88D5C618-F03E-EA92-CAEB-516FEDC4153F}"/>
+                <a16:creationId xmlns:a16="http://schemas.microsoft.com/office/drawing/2014/main" id="{C3648DAC-BE93-31A0-D0B9-F20BB1606568}"/>
               </a:ext>
             </a:extLst>
           </p:cNvPr>
@@ -5046,16 +5072,71 @@
             <p:ph type="title"/>
           </p:nvPr>
         </p:nvSpPr>
-        <p:spPr/>
-        <p:txBody>
-          <a:bodyPr/>
+        <p:spPr>
+          <a:xfrm>
+            <a:off x="236669" y="89257"/>
+            <a:ext cx="8686799" cy="402335"/>
+          </a:xfrm>
+        </p:spPr>
+        <p:txBody>
+          <a:bodyPr anchor="ctr">
+            <a:normAutofit/>
+          </a:bodyPr>
           <a:lstStyle/>
           <a:p>
             <a:r>
-              <a:rPr lang="en-US"/>
-              <a:t>C Code Generation</a:t>
-            </a:r>
-            <a:endParaRPr lang="en-US" dirty="0"/>
+              <a:rPr lang="en-US" sz="2100"/>
+              <a:t>Verilog Generation</a:t>
+            </a:r>
+          </a:p>
+        </p:txBody>
+      </p:sp>
+      <p:sp>
+        <p:nvSpPr>
+          <p:cNvPr id="4" name="Content Placeholder 3">
+            <a:extLst>
+              <a:ext uri="{FF2B5EF4-FFF2-40B4-BE49-F238E27FC236}">
+                <a16:creationId xmlns:a16="http://schemas.microsoft.com/office/drawing/2014/main" id="{CFBE5B1C-0CCE-274E-A635-DE186842EDA0}"/>
+              </a:ext>
+            </a:extLst>
+          </p:cNvPr>
+          <p:cNvSpPr>
+            <a:spLocks noGrp="1"/>
+          </p:cNvSpPr>
+          <p:nvPr>
+            <p:ph idx="1"/>
+          </p:nvPr>
+        </p:nvSpPr>
+        <p:spPr>
+          <a:xfrm>
+            <a:off x="228600" y="595691"/>
+            <a:ext cx="8694868" cy="4185860"/>
+          </a:xfrm>
+        </p:spPr>
+        <p:txBody>
+          <a:bodyPr>
+            <a:normAutofit/>
+          </a:bodyPr>
+          <a:lstStyle/>
+          <a:p>
+            <a:r>
+              <a:rPr lang="en-US" dirty="0"/>
+              <a:t>Auto-generated module</a:t>
+            </a:r>
+          </a:p>
+          <a:p>
+            <a:pPr lvl="1"/>
+            <a:r>
+              <a:rPr lang="en-US" dirty="0"/>
+              <a:t>DEB instances</a:t>
+            </a:r>
+          </a:p>
+          <a:p>
+            <a:pPr lvl="1"/>
+            <a:r>
+              <a:rPr lang="en-US" dirty="0"/>
+              <a:t>PSEQCELL instances</a:t>
+            </a:r>
           </a:p>
         </p:txBody>
       </p:sp>
@@ -5064,7 +5145,7 @@
           <p:cNvPr id="3" name="Slide Number Placeholder 2">
             <a:extLst>
               <a:ext uri="{FF2B5EF4-FFF2-40B4-BE49-F238E27FC236}">
-                <a16:creationId xmlns:a16="http://schemas.microsoft.com/office/drawing/2014/main" id="{BFA39D36-0A8B-32C6-2137-D0867231D7B0}"/>
+                <a16:creationId xmlns:a16="http://schemas.microsoft.com/office/drawing/2014/main" id="{F7C76006-54E2-B092-FAA0-91B5E38E2CC0}"/>
               </a:ext>
             </a:extLst>
           </p:cNvPr>
@@ -5080,61 +5161,30 @@
           <a:bodyPr/>
           <a:lstStyle/>
           <a:p>
+            <a:pPr>
+              <a:spcAft>
+                <a:spcPts val="600"/>
+              </a:spcAft>
+            </a:pPr>
             <a:fld id="{A241CA56-04D4-487E-9E31-9A10C01A108A}" type="slidenum">
               <a:rPr lang="en-US" smtClean="0"/>
-              <a:pPr/>
+              <a:pPr>
+                <a:spcAft>
+                  <a:spcPts val="600"/>
+                </a:spcAft>
+              </a:pPr>
               <a:t>6</a:t>
             </a:fld>
-            <a:endParaRPr lang="en-US" dirty="0"/>
-          </a:p>
-        </p:txBody>
-      </p:sp>
-      <p:sp>
-        <p:nvSpPr>
-          <p:cNvPr id="4" name="Content Placeholder 3">
+            <a:endParaRPr lang="en-US"/>
+          </a:p>
+        </p:txBody>
+      </p:sp>
+      <p:pic>
+        <p:nvPicPr>
+          <p:cNvPr id="7" name="Picture 6">
             <a:extLst>
               <a:ext uri="{FF2B5EF4-FFF2-40B4-BE49-F238E27FC236}">
-                <a16:creationId xmlns:a16="http://schemas.microsoft.com/office/drawing/2014/main" id="{62EB3514-6148-6E08-9B86-E03EA5851AEC}"/>
-              </a:ext>
-            </a:extLst>
-          </p:cNvPr>
-          <p:cNvSpPr>
-            <a:spLocks noGrp="1"/>
-          </p:cNvSpPr>
-          <p:nvPr>
-            <p:ph idx="1"/>
-          </p:nvPr>
-        </p:nvSpPr>
-        <p:spPr/>
-        <p:txBody>
-          <a:bodyPr/>
-          <a:lstStyle/>
-          <a:p>
-            <a:r>
-              <a:rPr lang="en-US" dirty="0" err="1"/>
-              <a:t>Pwrcell_t</a:t>
-            </a:r>
-            <a:r>
-              <a:rPr lang="en-US" dirty="0"/>
-              <a:t> scaffolding (reference: </a:t>
-            </a:r>
-            <a:r>
-              <a:rPr lang="en-US" dirty="0" err="1"/>
-              <a:t>pwrcell.c</a:t>
-            </a:r>
-            <a:r>
-              <a:rPr lang="en-US" dirty="0"/>
-              <a:t>/h)</a:t>
-            </a:r>
-          </a:p>
-        </p:txBody>
-      </p:sp>
-      <p:pic>
-        <p:nvPicPr>
-          <p:cNvPr id="5" name="Picture 4" descr="demo_c_excerpt.png">
-            <a:extLst>
-              <a:ext uri="{FF2B5EF4-FFF2-40B4-BE49-F238E27FC236}">
-                <a16:creationId xmlns:a16="http://schemas.microsoft.com/office/drawing/2014/main" id="{AA7AE4CF-5392-C371-6EF8-924E79F873FE}"/>
+                <a16:creationId xmlns:a16="http://schemas.microsoft.com/office/drawing/2014/main" id="{8D8CDE50-2E35-F261-F14C-3C97E15BA304}"/>
               </a:ext>
             </a:extLst>
           </p:cNvPr>
@@ -5151,8 +5201,8 @@
         </p:blipFill>
         <p:spPr>
           <a:xfrm>
-            <a:off x="1455563" y="975578"/>
-            <a:ext cx="6228392" cy="3572231"/>
+            <a:off x="1957206" y="1500810"/>
+            <a:ext cx="5229588" cy="3048002"/>
           </a:xfrm>
           <a:prstGeom prst="rect">
             <a:avLst/>
@@ -5162,7 +5212,7 @@
     </p:spTree>
     <p:extLst>
       <p:ext uri="{BB962C8B-B14F-4D97-AF65-F5344CB8AC3E}">
-        <p14:creationId xmlns:p14="http://schemas.microsoft.com/office/powerpoint/2010/main" val="2358417163"/>
+        <p14:creationId xmlns:p14="http://schemas.microsoft.com/office/powerpoint/2010/main" val="1665871314"/>
       </p:ext>
     </p:extLst>
   </p:cSld>
@@ -5194,7 +5244,7 @@
           <p:cNvPr id="2" name="Title 1">
             <a:extLst>
               <a:ext uri="{FF2B5EF4-FFF2-40B4-BE49-F238E27FC236}">
-                <a16:creationId xmlns:a16="http://schemas.microsoft.com/office/drawing/2014/main" id="{C36DD87F-773E-2D44-42B8-4C021418BE1A}"/>
+                <a16:creationId xmlns:a16="http://schemas.microsoft.com/office/drawing/2014/main" id="{88D5C618-F03E-EA92-CAEB-516FEDC4153F}"/>
               </a:ext>
             </a:extLst>
           </p:cNvPr>
@@ -5205,30 +5255,46 @@
             <p:ph type="title"/>
           </p:nvPr>
         </p:nvSpPr>
-        <p:spPr>
-          <a:xfrm>
-            <a:off x="236669" y="89257"/>
-            <a:ext cx="8686799" cy="402335"/>
-          </a:xfrm>
-        </p:spPr>
-        <p:txBody>
-          <a:bodyPr anchor="ctr">
-            <a:normAutofit/>
-          </a:bodyPr>
+        <p:spPr/>
+        <p:txBody>
+          <a:bodyPr/>
           <a:lstStyle/>
           <a:p>
             <a:r>
-              <a:rPr lang="en-US" sz="2100"/>
-              <a:t>Provided </a:t>
-            </a:r>
-            <a:r>
-              <a:rPr lang="en-US" sz="2100" err="1"/>
-              <a:t>WaveDrom</a:t>
-            </a:r>
-            <a:r>
-              <a:rPr lang="en-US" sz="2100"/>
-              <a:t> Timing</a:t>
-            </a:r>
+              <a:rPr lang="en-US"/>
+              <a:t>C Code Generation</a:t>
+            </a:r>
+            <a:endParaRPr lang="en-US" dirty="0"/>
+          </a:p>
+        </p:txBody>
+      </p:sp>
+      <p:sp>
+        <p:nvSpPr>
+          <p:cNvPr id="3" name="Slide Number Placeholder 2">
+            <a:extLst>
+              <a:ext uri="{FF2B5EF4-FFF2-40B4-BE49-F238E27FC236}">
+                <a16:creationId xmlns:a16="http://schemas.microsoft.com/office/drawing/2014/main" id="{BFA39D36-0A8B-32C6-2137-D0867231D7B0}"/>
+              </a:ext>
+            </a:extLst>
+          </p:cNvPr>
+          <p:cNvSpPr>
+            <a:spLocks noGrp="1"/>
+          </p:cNvSpPr>
+          <p:nvPr>
+            <p:ph type="sldNum" sz="quarter" idx="10"/>
+          </p:nvPr>
+        </p:nvSpPr>
+        <p:spPr/>
+        <p:txBody>
+          <a:bodyPr/>
+          <a:lstStyle/>
+          <a:p>
+            <a:fld id="{A241CA56-04D4-487E-9E31-9A10C01A108A}" type="slidenum">
+              <a:rPr lang="en-US" smtClean="0"/>
+              <a:pPr/>
+              <a:t>7</a:t>
+            </a:fld>
+            <a:endParaRPr lang="en-US" dirty="0"/>
           </a:p>
         </p:txBody>
       </p:sp>
@@ -5237,7 +5303,7 @@
           <p:cNvPr id="4" name="Content Placeholder 3">
             <a:extLst>
               <a:ext uri="{FF2B5EF4-FFF2-40B4-BE49-F238E27FC236}">
-                <a16:creationId xmlns:a16="http://schemas.microsoft.com/office/drawing/2014/main" id="{1AD536A7-7BF6-388F-1461-93871DF3CD95}"/>
+                <a16:creationId xmlns:a16="http://schemas.microsoft.com/office/drawing/2014/main" id="{62EB3514-6148-6E08-9B86-E03EA5851AEC}"/>
               </a:ext>
             </a:extLst>
           </p:cNvPr>
@@ -5248,31 +5314,36 @@
             <p:ph idx="1"/>
           </p:nvPr>
         </p:nvSpPr>
-        <p:spPr>
-          <a:xfrm>
-            <a:off x="228600" y="595691"/>
-            <a:ext cx="4245909" cy="4185860"/>
-          </a:xfrm>
-        </p:spPr>
-        <p:txBody>
-          <a:bodyPr>
-            <a:normAutofit/>
-          </a:bodyPr>
+        <p:spPr/>
+        <p:txBody>
+          <a:bodyPr/>
           <a:lstStyle/>
           <a:p>
             <a:r>
+              <a:rPr lang="en-US" dirty="0" err="1"/>
+              <a:t>Pwrcell_t</a:t>
+            </a:r>
+            <a:r>
               <a:rPr lang="en-US" dirty="0"/>
-              <a:t>Simulated from dependency graph (not RTL cycle-accurate)</a:t>
+              <a:t> scaffolding (reference: </a:t>
+            </a:r>
+            <a:r>
+              <a:rPr lang="en-US" dirty="0" err="1"/>
+              <a:t>pwrcell.c</a:t>
+            </a:r>
+            <a:r>
+              <a:rPr lang="en-US" dirty="0"/>
+              <a:t>/h)</a:t>
             </a:r>
           </a:p>
         </p:txBody>
       </p:sp>
       <p:pic>
         <p:nvPicPr>
-          <p:cNvPr id="5" name="Picture 4" descr="demo_wavedrom_png.png">
+          <p:cNvPr id="7" name="Picture 6">
             <a:extLst>
               <a:ext uri="{FF2B5EF4-FFF2-40B4-BE49-F238E27FC236}">
-                <a16:creationId xmlns:a16="http://schemas.microsoft.com/office/drawing/2014/main" id="{CF1E3F9D-3F9B-386F-660E-7B322DB96315}"/>
+                <a16:creationId xmlns:a16="http://schemas.microsoft.com/office/drawing/2014/main" id="{3C7CA831-F815-74A4-8D57-4F6405ED175E}"/>
               </a:ext>
             </a:extLst>
           </p:cNvPr>
@@ -5283,65 +5354,24 @@
         </p:nvPicPr>
         <p:blipFill>
           <a:blip r:embed="rId2"/>
-          <a:srcRect l="5240" r="11585" b="2"/>
           <a:stretch>
             <a:fillRect/>
           </a:stretch>
         </p:blipFill>
         <p:spPr>
           <a:xfrm>
-            <a:off x="4665009" y="595691"/>
-            <a:ext cx="4245909" cy="4185860"/>
+            <a:off x="2097763" y="1047750"/>
+            <a:ext cx="4964610" cy="3048000"/>
           </a:xfrm>
           <a:prstGeom prst="rect">
             <a:avLst/>
           </a:prstGeom>
-          <a:noFill/>
         </p:spPr>
       </p:pic>
-      <p:sp>
-        <p:nvSpPr>
-          <p:cNvPr id="3" name="Slide Number Placeholder 2">
-            <a:extLst>
-              <a:ext uri="{FF2B5EF4-FFF2-40B4-BE49-F238E27FC236}">
-                <a16:creationId xmlns:a16="http://schemas.microsoft.com/office/drawing/2014/main" id="{8C499031-D735-8FA4-4926-1CA115C98638}"/>
-              </a:ext>
-            </a:extLst>
-          </p:cNvPr>
-          <p:cNvSpPr>
-            <a:spLocks noGrp="1"/>
-          </p:cNvSpPr>
-          <p:nvPr>
-            <p:ph type="sldNum" sz="quarter" idx="10"/>
-          </p:nvPr>
-        </p:nvSpPr>
-        <p:spPr/>
-        <p:txBody>
-          <a:bodyPr/>
-          <a:lstStyle/>
-          <a:p>
-            <a:pPr>
-              <a:spcAft>
-                <a:spcPts val="600"/>
-              </a:spcAft>
-            </a:pPr>
-            <a:fld id="{A241CA56-04D4-487E-9E31-9A10C01A108A}" type="slidenum">
-              <a:rPr lang="en-US" smtClean="0"/>
-              <a:pPr>
-                <a:spcAft>
-                  <a:spcPts val="600"/>
-                </a:spcAft>
-              </a:pPr>
-              <a:t>7</a:t>
-            </a:fld>
-            <a:endParaRPr lang="en-US"/>
-          </a:p>
-        </p:txBody>
-      </p:sp>
     </p:spTree>
     <p:extLst>
       <p:ext uri="{BB962C8B-B14F-4D97-AF65-F5344CB8AC3E}">
-        <p14:creationId xmlns:p14="http://schemas.microsoft.com/office/powerpoint/2010/main" val="3271740098"/>
+        <p14:creationId xmlns:p14="http://schemas.microsoft.com/office/powerpoint/2010/main" val="2358417163"/>
       </p:ext>
     </p:extLst>
   </p:cSld>
@@ -5373,7 +5403,7 @@
           <p:cNvPr id="2" name="Title 1">
             <a:extLst>
               <a:ext uri="{FF2B5EF4-FFF2-40B4-BE49-F238E27FC236}">
-                <a16:creationId xmlns:a16="http://schemas.microsoft.com/office/drawing/2014/main" id="{B811A830-B270-8E0E-79A3-4FC55BA6685E}"/>
+                <a16:creationId xmlns:a16="http://schemas.microsoft.com/office/drawing/2014/main" id="{C36DD87F-773E-2D44-42B8-4C021418BE1A}"/>
               </a:ext>
             </a:extLst>
           </p:cNvPr>
@@ -5398,57 +5428,60 @@
           <a:p>
             <a:r>
               <a:rPr lang="en-US" sz="2100"/>
-              <a:t>Tooling &amp; Quality</a:t>
-            </a:r>
-          </a:p>
-        </p:txBody>
-      </p:sp>
-      <p:pic>
-        <p:nvPicPr>
-          <p:cNvPr id="6" name="Content Placeholder 5">
+              <a:t>Provided </a:t>
+            </a:r>
+            <a:r>
+              <a:rPr lang="en-US" sz="2100" err="1"/>
+              <a:t>WaveDrom</a:t>
+            </a:r>
+            <a:r>
+              <a:rPr lang="en-US" sz="2100"/>
+              <a:t> Timing</a:t>
+            </a:r>
+          </a:p>
+        </p:txBody>
+      </p:sp>
+      <p:sp>
+        <p:nvSpPr>
+          <p:cNvPr id="4" name="Content Placeholder 3">
             <a:extLst>
               <a:ext uri="{FF2B5EF4-FFF2-40B4-BE49-F238E27FC236}">
-                <a16:creationId xmlns:a16="http://schemas.microsoft.com/office/drawing/2014/main" id="{3B553F47-97B9-03D7-78A0-25DF8576F5C3}"/>
+                <a16:creationId xmlns:a16="http://schemas.microsoft.com/office/drawing/2014/main" id="{1AD536A7-7BF6-388F-1461-93871DF3CD95}"/>
               </a:ext>
             </a:extLst>
           </p:cNvPr>
-          <p:cNvPicPr>
-            <a:picLocks noGrp="1" noChangeAspect="1"/>
-          </p:cNvPicPr>
+          <p:cNvSpPr>
+            <a:spLocks noGrp="1"/>
+          </p:cNvSpPr>
           <p:nvPr>
             <p:ph idx="1"/>
           </p:nvPr>
-        </p:nvPicPr>
-        <p:blipFill>
-          <a:blip r:embed="rId2" cstate="print">
-            <a:extLst>
-              <a:ext uri="{28A0092B-C50C-407E-A947-70E740481C1C}">
-                <a14:useLocalDpi xmlns:a14="http://schemas.microsoft.com/office/drawing/2010/main" val="0"/>
-              </a:ext>
-            </a:extLst>
-          </a:blip>
-          <a:srcRect t="15380" b="46413"/>
-          <a:stretch>
-            <a:fillRect/>
-          </a:stretch>
-        </p:blipFill>
+        </p:nvSpPr>
         <p:spPr>
           <a:xfrm>
             <a:off x="228600" y="595691"/>
-            <a:ext cx="8682318" cy="4185860"/>
-          </a:xfrm>
-          <a:prstGeom prst="rect">
-            <a:avLst/>
-          </a:prstGeom>
-          <a:noFill/>
-        </p:spPr>
-      </p:pic>
+            <a:ext cx="4245909" cy="4185860"/>
+          </a:xfrm>
+        </p:spPr>
+        <p:txBody>
+          <a:bodyPr>
+            <a:normAutofit/>
+          </a:bodyPr>
+          <a:lstStyle/>
+          <a:p>
+            <a:r>
+              <a:rPr lang="en-US" dirty="0"/>
+              <a:t>Simulated from dependency graph (not RTL cycle-accurate)</a:t>
+            </a:r>
+          </a:p>
+        </p:txBody>
+      </p:sp>
       <p:sp>
         <p:nvSpPr>
           <p:cNvPr id="3" name="Slide Number Placeholder 2">
             <a:extLst>
               <a:ext uri="{FF2B5EF4-FFF2-40B4-BE49-F238E27FC236}">
-                <a16:creationId xmlns:a16="http://schemas.microsoft.com/office/drawing/2014/main" id="{8D504C4F-9CE8-E6C3-BCEA-4AAC89D4F2C2}"/>
+                <a16:creationId xmlns:a16="http://schemas.microsoft.com/office/drawing/2014/main" id="{8C499031-D735-8FA4-4926-1CA115C98638}"/>
               </a:ext>
             </a:extLst>
           </p:cNvPr>
@@ -5482,6 +5515,208 @@
           </a:p>
         </p:txBody>
       </p:sp>
+      <p:pic>
+        <p:nvPicPr>
+          <p:cNvPr id="7" name="Picture 6">
+            <a:extLst>
+              <a:ext uri="{FF2B5EF4-FFF2-40B4-BE49-F238E27FC236}">
+                <a16:creationId xmlns:a16="http://schemas.microsoft.com/office/drawing/2014/main" id="{EC080BDF-FF73-F0E8-EFF6-93A2AA6B2D7A}"/>
+              </a:ext>
+            </a:extLst>
+          </p:cNvPr>
+          <p:cNvPicPr>
+            <a:picLocks noChangeAspect="1"/>
+          </p:cNvPicPr>
+          <p:nvPr/>
+        </p:nvPicPr>
+        <p:blipFill>
+          <a:blip r:embed="rId2"/>
+          <a:stretch>
+            <a:fillRect/>
+          </a:stretch>
+        </p:blipFill>
+        <p:spPr>
+          <a:xfrm>
+            <a:off x="385990" y="2419350"/>
+            <a:ext cx="3352800" cy="2252133"/>
+          </a:xfrm>
+          <a:prstGeom prst="rect">
+            <a:avLst/>
+          </a:prstGeom>
+        </p:spPr>
+      </p:pic>
+      <p:pic>
+        <p:nvPicPr>
+          <p:cNvPr id="9" name="Picture 8">
+            <a:extLst>
+              <a:ext uri="{FF2B5EF4-FFF2-40B4-BE49-F238E27FC236}">
+                <a16:creationId xmlns:a16="http://schemas.microsoft.com/office/drawing/2014/main" id="{BA7E1AF9-0DBA-F479-6AFC-BA8C65910E86}"/>
+              </a:ext>
+            </a:extLst>
+          </p:cNvPr>
+          <p:cNvPicPr>
+            <a:picLocks noChangeAspect="1"/>
+          </p:cNvPicPr>
+          <p:nvPr/>
+        </p:nvPicPr>
+        <p:blipFill>
+          <a:blip r:embed="rId3" cstate="print">
+            <a:extLst>
+              <a:ext uri="{28A0092B-C50C-407E-A947-70E740481C1C}">
+                <a14:useLocalDpi xmlns:a14="http://schemas.microsoft.com/office/drawing/2010/main" val="0"/>
+              </a:ext>
+            </a:extLst>
+          </a:blip>
+          <a:stretch>
+            <a:fillRect/>
+          </a:stretch>
+        </p:blipFill>
+        <p:spPr>
+          <a:xfrm>
+            <a:off x="4182932" y="754223"/>
+            <a:ext cx="4732468" cy="3883887"/>
+          </a:xfrm>
+          <a:prstGeom prst="rect">
+            <a:avLst/>
+          </a:prstGeom>
+        </p:spPr>
+      </p:pic>
+    </p:spTree>
+    <p:extLst>
+      <p:ext uri="{BB962C8B-B14F-4D97-AF65-F5344CB8AC3E}">
+        <p14:creationId xmlns:p14="http://schemas.microsoft.com/office/powerpoint/2010/main" val="3271740098"/>
+      </p:ext>
+    </p:extLst>
+  </p:cSld>
+  <p:clrMapOvr>
+    <a:masterClrMapping/>
+  </p:clrMapOvr>
+</p:sld>
+</file>
+
+<file path=ppt/slides/slide9.xml><?xml version="1.0" encoding="utf-8"?>
+<p:sld xmlns:a="http://schemas.openxmlformats.org/drawingml/2006/main" xmlns:r="http://schemas.openxmlformats.org/officeDocument/2006/relationships" xmlns:p="http://schemas.openxmlformats.org/presentationml/2006/main">
+  <p:cSld>
+    <p:spTree>
+      <p:nvGrpSpPr>
+        <p:cNvPr id="1" name=""/>
+        <p:cNvGrpSpPr/>
+        <p:nvPr/>
+      </p:nvGrpSpPr>
+      <p:grpSpPr>
+        <a:xfrm>
+          <a:off x="0" y="0"/>
+          <a:ext cx="0" cy="0"/>
+          <a:chOff x="0" y="0"/>
+          <a:chExt cx="0" cy="0"/>
+        </a:xfrm>
+      </p:grpSpPr>
+      <p:sp>
+        <p:nvSpPr>
+          <p:cNvPr id="2" name="Title 1">
+            <a:extLst>
+              <a:ext uri="{FF2B5EF4-FFF2-40B4-BE49-F238E27FC236}">
+                <a16:creationId xmlns:a16="http://schemas.microsoft.com/office/drawing/2014/main" id="{B811A830-B270-8E0E-79A3-4FC55BA6685E}"/>
+              </a:ext>
+            </a:extLst>
+          </p:cNvPr>
+          <p:cNvSpPr>
+            <a:spLocks noGrp="1"/>
+          </p:cNvSpPr>
+          <p:nvPr>
+            <p:ph type="title"/>
+          </p:nvPr>
+        </p:nvSpPr>
+        <p:spPr>
+          <a:xfrm>
+            <a:off x="236669" y="89257"/>
+            <a:ext cx="8686799" cy="402335"/>
+          </a:xfrm>
+        </p:spPr>
+        <p:txBody>
+          <a:bodyPr anchor="ctr">
+            <a:normAutofit/>
+          </a:bodyPr>
+          <a:lstStyle/>
+          <a:p>
+            <a:r>
+              <a:rPr lang="en-US" sz="2100"/>
+              <a:t>Tooling &amp; Quality</a:t>
+            </a:r>
+          </a:p>
+        </p:txBody>
+      </p:sp>
+      <p:sp>
+        <p:nvSpPr>
+          <p:cNvPr id="3" name="Slide Number Placeholder 2">
+            <a:extLst>
+              <a:ext uri="{FF2B5EF4-FFF2-40B4-BE49-F238E27FC236}">
+                <a16:creationId xmlns:a16="http://schemas.microsoft.com/office/drawing/2014/main" id="{8D504C4F-9CE8-E6C3-BCEA-4AAC89D4F2C2}"/>
+              </a:ext>
+            </a:extLst>
+          </p:cNvPr>
+          <p:cNvSpPr>
+            <a:spLocks noGrp="1"/>
+          </p:cNvSpPr>
+          <p:nvPr>
+            <p:ph type="sldNum" sz="quarter" idx="10"/>
+          </p:nvPr>
+        </p:nvSpPr>
+        <p:spPr/>
+        <p:txBody>
+          <a:bodyPr/>
+          <a:lstStyle/>
+          <a:p>
+            <a:pPr>
+              <a:spcAft>
+                <a:spcPts val="600"/>
+              </a:spcAft>
+            </a:pPr>
+            <a:fld id="{A241CA56-04D4-487E-9E31-9A10C01A108A}" type="slidenum">
+              <a:rPr lang="en-US" smtClean="0"/>
+              <a:pPr>
+                <a:spcAft>
+                  <a:spcPts val="600"/>
+                </a:spcAft>
+              </a:pPr>
+              <a:t>9</a:t>
+            </a:fld>
+            <a:endParaRPr lang="en-US"/>
+          </a:p>
+        </p:txBody>
+      </p:sp>
+      <p:pic>
+        <p:nvPicPr>
+          <p:cNvPr id="8" name="Content Placeholder 7">
+            <a:extLst>
+              <a:ext uri="{FF2B5EF4-FFF2-40B4-BE49-F238E27FC236}">
+                <a16:creationId xmlns:a16="http://schemas.microsoft.com/office/drawing/2014/main" id="{62719956-3303-1232-C28C-38F6381D68A3}"/>
+              </a:ext>
+            </a:extLst>
+          </p:cNvPr>
+          <p:cNvPicPr>
+            <a:picLocks noGrp="1" noChangeAspect="1"/>
+          </p:cNvPicPr>
+          <p:nvPr>
+            <p:ph idx="1"/>
+          </p:nvPr>
+        </p:nvPicPr>
+        <p:blipFill>
+          <a:blip r:embed="rId2"/>
+          <a:stretch>
+            <a:fillRect/>
+          </a:stretch>
+        </p:blipFill>
+        <p:spPr>
+          <a:xfrm>
+            <a:off x="507820" y="595313"/>
+            <a:ext cx="8123597" cy="4186237"/>
+          </a:xfrm>
+          <a:prstGeom prst="rect">
+            <a:avLst/>
+          </a:prstGeom>
+        </p:spPr>
+      </p:pic>
     </p:spTree>
     <p:extLst>
       <p:ext uri="{BB962C8B-B14F-4D97-AF65-F5344CB8AC3E}">

</xml_diff>